<commit_message>
Assurance turno 2-4 (13-19 OCT): focos con HAP/CBP pasan a N1 por indicación del usuario
Co-Authored-By: Claude Opus 5.5 <noreply@anthropic.com>
Claude-Session: https://claude.ai/code/session_017MaLNPnWzNhW9Tdfmjv67V
</commit_message>
<xml_diff>
--- a/ASSURANCE_TURNO_2-4_13-19_OCT.pptx
+++ b/ASSURANCE_TURNO_2-4_13-19_OCT.pptx
@@ -2227,7 +2227,7 @@
                           <a:ea typeface="Arial" pitchFamily="34" charset="-122"/>
                           <a:cs typeface="Arial" pitchFamily="34" charset="-120"/>
                         </a:rPr>
-                        <a:t>N2 · CRITICIDAD INTERMEDIA</a:t>
+                        <a:t>N1 · CRITICIDAD ALTA</a:t>
                       </a:r>
                       <a:endParaRPr lang="en-US" sz="800" dirty="0">
                         <a:latin typeface="Arial" charset="0"/>
@@ -2274,7 +2274,7 @@
                       <a:tailEnd type="none" w="med" len="med"/>
                     </a:lnB>
                     <a:solidFill>
-                      <a:srgbClr val="E67E22"/>
+                      <a:srgbClr val="C62828"/>
                     </a:solidFill>
                   </a:tcPr>
                 </a:tc>
@@ -2321,7 +2321,7 @@
                       <a:r>
                         <a:rPr lang="en-US" sz="630" b="1" dirty="0" i="0">
                           <a:solidFill>
-                            <a:srgbClr val="B35C00"/>
+                            <a:srgbClr val="C62828"/>
                           </a:solidFill>
                           <a:latin typeface="Arial" pitchFamily="34" charset="0"/>
                           <a:ea typeface="Arial" pitchFamily="34" charset="-122"/>
@@ -2692,7 +2692,7 @@
                           <a:ea typeface="Arial" pitchFamily="34" charset="-122"/>
                           <a:cs typeface="Arial" pitchFamily="34" charset="-120"/>
                         </a:rPr>
-                        <a:t>N2 · CRITICIDAD INTERMEDIA</a:t>
+                        <a:t>N1 · CRITICIDAD ALTA</a:t>
                       </a:r>
                       <a:endParaRPr lang="en-US" sz="800" dirty="0">
                         <a:latin typeface="Arial" charset="0"/>
@@ -2749,7 +2749,7 @@
                       <a:tailEnd type="none" w="med" len="med"/>
                     </a:lnB>
                     <a:solidFill>
-                      <a:srgbClr val="E67E22"/>
+                      <a:srgbClr val="C62828"/>
                     </a:solidFill>
                   </a:tcPr>
                 </a:tc>
@@ -2796,7 +2796,7 @@
                       <a:r>
                         <a:rPr lang="en-US" sz="630" b="1" dirty="0" i="0">
                           <a:solidFill>
-                            <a:srgbClr val="B35C00"/>
+                            <a:srgbClr val="C62828"/>
                           </a:solidFill>
                           <a:latin typeface="Arial" pitchFamily="34" charset="0"/>
                           <a:ea typeface="Arial" pitchFamily="34" charset="-122"/>
@@ -3167,7 +3167,7 @@
                           <a:ea typeface="Arial" pitchFamily="34" charset="-122"/>
                           <a:cs typeface="Arial" pitchFamily="34" charset="-120"/>
                         </a:rPr>
-                        <a:t>N2 · CRITICIDAD INTERMEDIA</a:t>
+                        <a:t>N1 · CRITICIDAD ALTA</a:t>
                       </a:r>
                       <a:endParaRPr lang="en-US" sz="800" dirty="0">
                         <a:latin typeface="Arial" charset="0"/>
@@ -3224,7 +3224,7 @@
                       <a:tailEnd type="none" w="med" len="med"/>
                     </a:lnB>
                     <a:solidFill>
-                      <a:srgbClr val="E67E22"/>
+                      <a:srgbClr val="C62828"/>
                     </a:solidFill>
                   </a:tcPr>
                 </a:tc>
@@ -3271,7 +3271,7 @@
                       <a:r>
                         <a:rPr lang="en-US" sz="630" b="1" dirty="0" i="0">
                           <a:solidFill>
-                            <a:srgbClr val="B35C00"/>
+                            <a:srgbClr val="C62828"/>
                           </a:solidFill>
                           <a:latin typeface="Arial" pitchFamily="34" charset="0"/>
                           <a:ea typeface="Arial" pitchFamily="34" charset="-122"/>
@@ -3674,7 +3674,7 @@
                           <a:ea typeface="Arial" pitchFamily="34" charset="-122"/>
                           <a:cs typeface="Arial" pitchFamily="34" charset="-120"/>
                         </a:rPr>
-                        <a:t>N2 · CRITICIDAD INTERMEDIA</a:t>
+                        <a:t>N1 · CRITICIDAD ALTA</a:t>
                       </a:r>
                       <a:endParaRPr lang="en-US" sz="800" dirty="0">
                         <a:latin typeface="Arial" charset="0"/>
@@ -3721,7 +3721,7 @@
                       <a:tailEnd type="none" w="med" len="med"/>
                     </a:lnB>
                     <a:solidFill>
-                      <a:srgbClr val="E67E22"/>
+                      <a:srgbClr val="C62828"/>
                     </a:solidFill>
                   </a:tcPr>
                 </a:tc>
@@ -3768,7 +3768,7 @@
                       <a:r>
                         <a:rPr lang="en-US" sz="630" b="1" dirty="0" i="0">
                           <a:solidFill>
-                            <a:srgbClr val="B35C00"/>
+                            <a:srgbClr val="C62828"/>
                           </a:solidFill>
                           <a:latin typeface="Arial" pitchFamily="34" charset="0"/>
                           <a:ea typeface="Arial" pitchFamily="34" charset="-122"/>
@@ -4139,7 +4139,7 @@
                           <a:ea typeface="Arial" pitchFamily="34" charset="-122"/>
                           <a:cs typeface="Arial" pitchFamily="34" charset="-120"/>
                         </a:rPr>
-                        <a:t>N2 · CRITICIDAD INTERMEDIA</a:t>
+                        <a:t>N1 · CRITICIDAD ALTA</a:t>
                       </a:r>
                       <a:endParaRPr lang="en-US" sz="800" dirty="0">
                         <a:latin typeface="Arial" charset="0"/>
@@ -4186,7 +4186,7 @@
                       <a:tailEnd type="none" w="med" len="med"/>
                     </a:lnB>
                     <a:solidFill>
-                      <a:srgbClr val="E67E22"/>
+                      <a:srgbClr val="C62828"/>
                     </a:solidFill>
                   </a:tcPr>
                 </a:tc>
@@ -4233,7 +4233,7 @@
                       <a:r>
                         <a:rPr lang="en-US" sz="630" b="1" dirty="0" i="0">
                           <a:solidFill>
-                            <a:srgbClr val="B35C00"/>
+                            <a:srgbClr val="C62828"/>
                           </a:solidFill>
                           <a:latin typeface="Arial" pitchFamily="34" charset="0"/>
                           <a:ea typeface="Arial" pitchFamily="34" charset="-122"/>

</xml_diff>

<commit_message>
Assurance turno 2-4 (13-19 OCT): focos con HAP en N1 y focos con CBP en N2
Co-Authored-By: Claude Opus 5.5 <noreply@anthropic.com>
Claude-Session: https://claude.ai/code/session_017MaLNPnWzNhW9Tdfmjv67V
</commit_message>
<xml_diff>
--- a/ASSURANCE_TURNO_2-4_13-19_OCT.pptx
+++ b/ASSURANCE_TURNO_2-4_13-19_OCT.pptx
@@ -2770,481 +2770,6 @@
                           <a:ea typeface="Arial" pitchFamily="34" charset="-122"/>
                           <a:cs typeface="Arial" pitchFamily="34" charset="-120"/>
                         </a:rPr>
-                        <a:t>Anclaje y SPDC en bordes. </a:t>
-                      </a:r>
-                      <a:r>
-                        <a:rPr lang="en-US" sz="630" b="0" i="0" dirty="0">
-                          <a:solidFill>
-                            <a:srgbClr val="222222"/>
-                          </a:solidFill>
-                          <a:latin typeface="Arial" pitchFamily="34" charset="0"/>
-                          <a:ea typeface="Arial" pitchFamily="34" charset="-122"/>
-                          <a:cs typeface="Arial" pitchFamily="34" charset="-120"/>
-                        </a:rPr>
-                        <a:t>Verificar al inicio del turno en frentes de canaletas y retiro de geosintéticos: punto de anclaje o roseta habilitado en el sector, trabajador conectado con su SPDC al trabajar próximo a bordes y arneses guardados en lugar habilitado (no dentro de tuberías); el supervisor lo confirma antes de iniciar.</a:t>
-                      </a:r>
-                      <a:endParaRPr lang="en-US" sz="630" dirty="0">
-                        <a:latin typeface="Arial" charset="0"/>
-                        <a:ea typeface="Arial" charset="0"/>
-                        <a:cs typeface="Arial" charset="0"/>
-                      </a:endParaRPr>
-                    </a:p>
-                    <a:p>
-                      <a:pPr marL="0" indent="0">
-                        <a:buNone/>
-                      </a:pPr>
-                      <a:r>
-                        <a:rPr lang="en-US" sz="630" b="1" dirty="0" i="0">
-                          <a:solidFill>
-                            <a:srgbClr val="C62828"/>
-                          </a:solidFill>
-                          <a:latin typeface="Arial" pitchFamily="34" charset="0"/>
-                          <a:ea typeface="Arial" pitchFamily="34" charset="-122"/>
-                          <a:cs typeface="Arial" pitchFamily="34" charset="-120"/>
-                        </a:rPr>
-                        <a:t>Criterio de restricción: </a:t>
-                      </a:r>
-                      <a:r>
-                        <a:rPr lang="en-US" sz="630" b="0" dirty="0" i="0">
-                          <a:solidFill>
-                            <a:srgbClr val="222222"/>
-                          </a:solidFill>
-                          <a:latin typeface="Arial" pitchFamily="34" charset="0"/>
-                          <a:ea typeface="Arial" pitchFamily="34" charset="-122"/>
-                          <a:cs typeface="Arial" pitchFamily="34" charset="-120"/>
-                        </a:rPr>
-                        <a:t>Se detiene la tarea si hay trabajadores próximos a bordes o desniveles sin anclaje habilitado o sin su SPDC conectado.</a:t>
-                      </a:r>
-                      <a:endParaRPr lang="en-US" sz="630" dirty="0">
-                        <a:latin typeface="Arial" charset="0"/>
-                        <a:ea typeface="Arial" charset="0"/>
-                        <a:cs typeface="Arial" charset="0"/>
-                      </a:endParaRPr>
-                    </a:p>
-                  </a:txBody>
-                  <a:tcPr marL="50800" marR="50800" marT="25400" marB="25400" anchor="ctr">
-                    <a:lnL w="9525" cap="flat" cmpd="sng" algn="ctr">
-                      <a:solidFill>
-                        <a:srgbClr val="C9D3E0"/>
-                      </a:solidFill>
-                      <a:prstDash val="solid"/>
-                      <a:round/>
-                      <a:headEnd type="none" w="med" len="med"/>
-                      <a:tailEnd type="none" w="med" len="med"/>
-                    </a:lnL>
-                    <a:lnR w="9525" cap="flat" cmpd="sng" algn="ctr">
-                      <a:solidFill>
-                        <a:srgbClr val="C9D3E0"/>
-                      </a:solidFill>
-                      <a:prstDash val="solid"/>
-                      <a:round/>
-                      <a:headEnd type="none" w="med" len="med"/>
-                      <a:tailEnd type="none" w="med" len="med"/>
-                    </a:lnR>
-                    <a:lnT w="9525" cap="flat" cmpd="sng" algn="ctr">
-                      <a:solidFill>
-                        <a:srgbClr val="C9D3E0"/>
-                      </a:solidFill>
-                      <a:prstDash val="solid"/>
-                      <a:round/>
-                      <a:headEnd type="none" w="med" len="med"/>
-                      <a:tailEnd type="none" w="med" len="med"/>
-                    </a:lnT>
-                    <a:lnB w="9525" cap="flat" cmpd="sng" algn="ctr">
-                      <a:solidFill>
-                        <a:srgbClr val="C9D3E0"/>
-                      </a:solidFill>
-                      <a:prstDash val="solid"/>
-                      <a:round/>
-                      <a:headEnd type="none" w="med" len="med"/>
-                      <a:tailEnd type="none" w="med" len="med"/>
-                    </a:lnB>
-                    <a:solidFill>
-                      <a:srgbClr val="F3F6FA"/>
-                    </a:solidFill>
-                  </a:tcPr>
-                </a:tc>
-                <a:tc>
-                  <a:txBody>
-                    <a:bodyPr/>
-                    <a:lstStyle/>
-                    <a:p>
-                      <a:pPr marL="0" indent="0">
-                        <a:buNone/>
-                      </a:pPr>
-                      <a:r>
-                        <a:rPr lang="en-US" sz="620" b="1" dirty="0" i="0">
-                          <a:solidFill>
-                            <a:srgbClr val="222222"/>
-                          </a:solidFill>
-                          <a:latin typeface="Arial" pitchFamily="34" charset="0"/>
-                          <a:ea typeface="Arial" pitchFamily="34" charset="-122"/>
-                          <a:cs typeface="Arial" pitchFamily="34" charset="-120"/>
-                        </a:rPr>
-                        <a:t>CBP ID 564344 – PUMA:</a:t>
-                      </a:r>
-                      <a:r>
-                        <a:rPr lang="en-US" sz="620" b="0" dirty="0" i="0">
-                          <a:solidFill>
-                            <a:srgbClr val="222222"/>
-                          </a:solidFill>
-                          <a:latin typeface="Arial" pitchFamily="34" charset="0"/>
-                          <a:ea typeface="Arial" pitchFamily="34" charset="-122"/>
-                          <a:cs typeface="Arial" pitchFamily="34" charset="-120"/>
-                        </a:rPr>
-                        <a:t> trabajador en borde de canaleta recibiendo láminas HDPE, sin conectar su SPDC a la roseta.</a:t>
-                      </a:r>
-                      <a:endParaRPr lang="en-US" sz="620" dirty="0">
-                        <a:latin typeface="Arial" charset="0"/>
-                        <a:ea typeface="Arial" charset="0"/>
-                        <a:cs typeface="Arial" charset="0"/>
-                      </a:endParaRPr>
-                    </a:p>
-                    <a:p>
-                      <a:pPr marL="0" indent="0">
-                        <a:buNone/>
-                      </a:pPr>
-                      <a:r>
-                        <a:rPr lang="en-US" sz="620" b="1" dirty="0" i="0">
-                          <a:solidFill>
-                            <a:srgbClr val="222222"/>
-                          </a:solidFill>
-                          <a:latin typeface="Arial" pitchFamily="34" charset="0"/>
-                          <a:ea typeface="Arial" pitchFamily="34" charset="-122"/>
-                          <a:cs typeface="Arial" pitchFamily="34" charset="-120"/>
-                        </a:rPr>
-                        <a:t>HBP ID 564341 / 564353 – PUMA:</a:t>
-                      </a:r>
-                      <a:r>
-                        <a:rPr lang="en-US" sz="620" b="0" dirty="0" i="0">
-                          <a:solidFill>
-                            <a:srgbClr val="222222"/>
-                          </a:solidFill>
-                          <a:latin typeface="Arial" pitchFamily="34" charset="0"/>
-                          <a:ea typeface="Arial" pitchFamily="34" charset="-122"/>
-                          <a:cs typeface="Arial" pitchFamily="34" charset="-120"/>
-                        </a:rPr>
-                        <a:t> sin anclaje para SPDC en retiro de geosintéticos / arnés acopiado dentro de tubería.</a:t>
-                      </a:r>
-                      <a:endParaRPr lang="en-US" sz="620" dirty="0">
-                        <a:latin typeface="Arial" charset="0"/>
-                        <a:ea typeface="Arial" charset="0"/>
-                        <a:cs typeface="Arial" charset="0"/>
-                      </a:endParaRPr>
-                    </a:p>
-                  </a:txBody>
-                  <a:tcPr marL="50800" marR="50800" marT="25400" marB="25400" anchor="ctr">
-                    <a:lnL w="9525" cap="flat" cmpd="sng" algn="ctr">
-                      <a:solidFill>
-                        <a:srgbClr val="C9D3E0"/>
-                      </a:solidFill>
-                      <a:prstDash val="solid"/>
-                      <a:round/>
-                      <a:headEnd type="none" w="med" len="med"/>
-                      <a:tailEnd type="none" w="med" len="med"/>
-                    </a:lnL>
-                    <a:lnR w="9525" cap="flat" cmpd="sng" algn="ctr">
-                      <a:solidFill>
-                        <a:srgbClr val="C9D3E0"/>
-                      </a:solidFill>
-                      <a:prstDash val="solid"/>
-                      <a:round/>
-                      <a:headEnd type="none" w="med" len="med"/>
-                      <a:tailEnd type="none" w="med" len="med"/>
-                    </a:lnR>
-                    <a:lnT w="9525" cap="flat" cmpd="sng" algn="ctr">
-                      <a:solidFill>
-                        <a:srgbClr val="C9D3E0"/>
-                      </a:solidFill>
-                      <a:prstDash val="solid"/>
-                      <a:round/>
-                      <a:headEnd type="none" w="med" len="med"/>
-                      <a:tailEnd type="none" w="med" len="med"/>
-                    </a:lnT>
-                    <a:lnB w="9525" cap="flat" cmpd="sng" algn="ctr">
-                      <a:solidFill>
-                        <a:srgbClr val="C9D3E0"/>
-                      </a:solidFill>
-                      <a:prstDash val="solid"/>
-                      <a:round/>
-                      <a:headEnd type="none" w="med" len="med"/>
-                      <a:tailEnd type="none" w="med" len="med"/>
-                    </a:lnB>
-                    <a:solidFill>
-                      <a:srgbClr val="F3F6FA"/>
-                    </a:solidFill>
-                  </a:tcPr>
-                </a:tc>
-                <a:tc>
-                  <a:txBody>
-                    <a:bodyPr/>
-                    <a:lstStyle/>
-                    <a:p>
-                      <a:pPr marL="0" indent="0">
-                        <a:buNone/>
-                      </a:pPr>
-                      <a:r>
-                        <a:rPr lang="en-US" sz="630" i="0" dirty="0" b="1">
-                          <a:solidFill>
-                            <a:srgbClr val="222222"/>
-                          </a:solidFill>
-                          <a:latin typeface="Arial" pitchFamily="34" charset="0"/>
-                          <a:ea typeface="Arial" pitchFamily="34" charset="-122"/>
-                          <a:cs typeface="Arial" pitchFamily="34" charset="-120"/>
-                        </a:rPr>
-                        <a:t>GCC + CdP Trabajos en Altura + ASP</a:t>
-                      </a:r>
-                      <a:r>
-                        <a:rPr lang="en-US" sz="630" i="0" dirty="0" b="0">
-                          <a:solidFill>
-                            <a:srgbClr val="222222"/>
-                          </a:solidFill>
-                          <a:latin typeface="Arial" pitchFamily="34" charset="0"/>
-                          <a:ea typeface="Arial" pitchFamily="34" charset="-122"/>
-                          <a:cs typeface="Arial" pitchFamily="34" charset="-120"/>
-                        </a:rPr>
-                        <a:t>: GCC de anclaje y SPDC al inicio del turno en cada frente de canaletas; ASP antes de trabajar en bordes.</a:t>
-                      </a:r>
-                      <a:endParaRPr lang="en-US" sz="630" dirty="0">
-                        <a:latin typeface="Arial" charset="0"/>
-                        <a:ea typeface="Arial" charset="0"/>
-                        <a:cs typeface="Arial" charset="0"/>
-                      </a:endParaRPr>
-                    </a:p>
-                  </a:txBody>
-                  <a:tcPr marL="50800" marR="50800" marT="25400" marB="25400" anchor="ctr">
-                    <a:lnL w="9525" cap="flat" cmpd="sng" algn="ctr">
-                      <a:solidFill>
-                        <a:srgbClr val="C9D3E0"/>
-                      </a:solidFill>
-                      <a:prstDash val="solid"/>
-                      <a:round/>
-                      <a:headEnd type="none" w="med" len="med"/>
-                      <a:tailEnd type="none" w="med" len="med"/>
-                    </a:lnL>
-                    <a:lnR w="9525" cap="flat" cmpd="sng" algn="ctr">
-                      <a:solidFill>
-                        <a:srgbClr val="C9D3E0"/>
-                      </a:solidFill>
-                      <a:prstDash val="solid"/>
-                      <a:round/>
-                      <a:headEnd type="none" w="med" len="med"/>
-                      <a:tailEnd type="none" w="med" len="med"/>
-                    </a:lnR>
-                    <a:lnT w="9525" cap="flat" cmpd="sng" algn="ctr">
-                      <a:solidFill>
-                        <a:srgbClr val="C9D3E0"/>
-                      </a:solidFill>
-                      <a:prstDash val="solid"/>
-                      <a:round/>
-                      <a:headEnd type="none" w="med" len="med"/>
-                      <a:tailEnd type="none" w="med" len="med"/>
-                    </a:lnT>
-                    <a:lnB w="9525" cap="flat" cmpd="sng" algn="ctr">
-                      <a:solidFill>
-                        <a:srgbClr val="C9D3E0"/>
-                      </a:solidFill>
-                      <a:prstDash val="solid"/>
-                      <a:round/>
-                      <a:headEnd type="none" w="med" len="med"/>
-                      <a:tailEnd type="none" w="med" len="med"/>
-                    </a:lnB>
-                    <a:solidFill>
-                      <a:srgbClr val="F3F6FA"/>
-                    </a:solidFill>
-                  </a:tcPr>
-                </a:tc>
-                <a:tc>
-                  <a:txBody>
-                    <a:bodyPr/>
-                    <a:lstStyle/>
-                    <a:p>
-                      <a:pPr marL="0" indent="0">
-                        <a:buNone/>
-                      </a:pPr>
-                      <a:r>
-                        <a:rPr lang="en-US" sz="630" i="0" dirty="0" b="0">
-                          <a:solidFill>
-                            <a:srgbClr val="222222"/>
-                          </a:solidFill>
-                          <a:latin typeface="Arial" pitchFamily="34" charset="0"/>
-                          <a:ea typeface="Arial" pitchFamily="34" charset="-122"/>
-                          <a:cs typeface="Arial" pitchFamily="34" charset="-120"/>
-                        </a:rPr>
-                        <a:t>Anclaje o roseta identificado / trabajador conectado al SPDC / arnés en lugar habilitado / registro fotográfico</a:t>
-                      </a:r>
-                      <a:endParaRPr lang="en-US" sz="630" dirty="0">
-                        <a:latin typeface="Arial" charset="0"/>
-                        <a:ea typeface="Arial" charset="0"/>
-                        <a:cs typeface="Arial" charset="0"/>
-                      </a:endParaRPr>
-                    </a:p>
-                  </a:txBody>
-                  <a:tcPr marL="50800" marR="50800" marT="25400" marB="25400" anchor="ctr">
-                    <a:lnL w="9525" cap="flat" cmpd="sng" algn="ctr">
-                      <a:solidFill>
-                        <a:srgbClr val="C9D3E0"/>
-                      </a:solidFill>
-                      <a:prstDash val="solid"/>
-                      <a:round/>
-                      <a:headEnd type="none" w="med" len="med"/>
-                      <a:tailEnd type="none" w="med" len="med"/>
-                    </a:lnL>
-                    <a:lnR w="9525" cap="flat" cmpd="sng" algn="ctr">
-                      <a:solidFill>
-                        <a:srgbClr val="C9D3E0"/>
-                      </a:solidFill>
-                      <a:prstDash val="solid"/>
-                      <a:round/>
-                      <a:headEnd type="none" w="med" len="med"/>
-                      <a:tailEnd type="none" w="med" len="med"/>
-                    </a:lnR>
-                    <a:lnT w="9525" cap="flat" cmpd="sng" algn="ctr">
-                      <a:solidFill>
-                        <a:srgbClr val="C9D3E0"/>
-                      </a:solidFill>
-                      <a:prstDash val="solid"/>
-                      <a:round/>
-                      <a:headEnd type="none" w="med" len="med"/>
-                      <a:tailEnd type="none" w="med" len="med"/>
-                    </a:lnT>
-                    <a:lnB w="9525" cap="flat" cmpd="sng" algn="ctr">
-                      <a:solidFill>
-                        <a:srgbClr val="C9D3E0"/>
-                      </a:solidFill>
-                      <a:prstDash val="solid"/>
-                      <a:round/>
-                      <a:headEnd type="none" w="med" len="med"/>
-                      <a:tailEnd type="none" w="med" len="med"/>
-                    </a:lnB>
-                    <a:solidFill>
-                      <a:srgbClr val="F3F6FA"/>
-                    </a:solidFill>
-                  </a:tcPr>
-                </a:tc>
-                <a:extLst>
-                  <a:ext uri="{0D108BD9-81ED-4DB2-BD59-A6C34878D82A}">
-                    <a16:rowId xmlns:a16="http://schemas.microsoft.com/office/drawing/2014/main" val="10002"/>
-                  </a:ext>
-                </a:extLst>
-              </a:tr>
-              <a:tr h="566928">
-                <a:tc>
-                  <a:txBody>
-                    <a:bodyPr/>
-                    <a:lstStyle/>
-                    <a:p>
-                      <a:pPr marL="0" indent="0" algn="ctr">
-                        <a:buNone/>
-                      </a:pPr>
-                      <a:r>
-                        <a:rPr lang="en-US" sz="1300" b="1" dirty="0">
-                          <a:solidFill>
-                            <a:srgbClr val="FFFFFF"/>
-                          </a:solidFill>
-                          <a:latin typeface="Arial" pitchFamily="34" charset="0"/>
-                          <a:ea typeface="Arial" charset="0"/>
-                          <a:cs typeface="Arial" pitchFamily="34" charset="-120"/>
-                        </a:rPr>
-                        <a:t>3</a:t>
-                      </a:r>
-                      <a:endParaRPr lang="en-US" sz="800" dirty="0">
-                        <a:latin typeface="Arial" charset="0"/>
-                        <a:ea typeface="Arial" charset="0"/>
-                        <a:cs typeface="Arial" charset="0"/>
-                      </a:endParaRPr>
-                    </a:p>
-                    <a:p>
-                      <a:pPr marL="0" indent="0" algn="ctr">
-                        <a:buNone/>
-                      </a:pPr>
-                      <a:r>
-                        <a:rPr lang="en-US" sz="750" b="1" dirty="0" i="0">
-                          <a:solidFill>
-                            <a:srgbClr val="FFFFFF"/>
-                          </a:solidFill>
-                          <a:latin typeface="Arial" pitchFamily="34" charset="0"/>
-                          <a:ea typeface="Arial" pitchFamily="34" charset="-122"/>
-                          <a:cs typeface="Arial" pitchFamily="34" charset="-120"/>
-                        </a:rPr>
-                        <a:t>N1 · CRITICIDAD ALTA</a:t>
-                      </a:r>
-                      <a:endParaRPr lang="en-US" sz="800" dirty="0">
-                        <a:latin typeface="Arial" charset="0"/>
-                        <a:ea typeface="Arial" charset="0"/>
-                        <a:cs typeface="Arial" charset="0"/>
-                      </a:endParaRPr>
-                    </a:p>
-                    <a:p>
-                      <a:pPr marL="0" indent="0" algn="ctr">
-                        <a:buNone/>
-                      </a:pPr>
-                      <a:endParaRPr lang="en-US" sz="800" dirty="0">
-                        <a:latin typeface="Arial" charset="0"/>
-                        <a:ea typeface="Arial" charset="0"/>
-                        <a:cs typeface="Arial" charset="0"/>
-                      </a:endParaRPr>
-                    </a:p>
-                  </a:txBody>
-                  <a:tcPr marL="50800" marR="50800" marT="25400" marB="25400" anchor="ctr">
-                    <a:lnL w="9525" cap="flat" cmpd="sng" algn="ctr">
-                      <a:solidFill>
-                        <a:srgbClr val="C9D3E0"/>
-                      </a:solidFill>
-                      <a:prstDash val="solid"/>
-                      <a:round/>
-                      <a:headEnd type="none" w="med" len="med"/>
-                      <a:tailEnd type="none" w="med" len="med"/>
-                    </a:lnL>
-                    <a:lnR w="9525" cap="flat" cmpd="sng" algn="ctr">
-                      <a:solidFill>
-                        <a:srgbClr val="C9D3E0"/>
-                      </a:solidFill>
-                      <a:prstDash val="solid"/>
-                      <a:round/>
-                      <a:headEnd type="none" w="med" len="med"/>
-                      <a:tailEnd type="none" w="med" len="med"/>
-                    </a:lnR>
-                    <a:lnT w="9525" cap="flat" cmpd="sng" algn="ctr">
-                      <a:solidFill>
-                        <a:srgbClr val="C9D3E0"/>
-                      </a:solidFill>
-                      <a:prstDash val="solid"/>
-                      <a:round/>
-                      <a:headEnd type="none" w="med" len="med"/>
-                      <a:tailEnd type="none" w="med" len="med"/>
-                    </a:lnT>
-                    <a:lnB w="9525" cap="flat" cmpd="sng" algn="ctr">
-                      <a:solidFill>
-                        <a:srgbClr val="C9D3E0"/>
-                      </a:solidFill>
-                      <a:prstDash val="solid"/>
-                      <a:round/>
-                      <a:headEnd type="none" w="med" len="med"/>
-                      <a:tailEnd type="none" w="med" len="med"/>
-                    </a:lnB>
-                    <a:solidFill>
-                      <a:srgbClr val="C62828"/>
-                    </a:solidFill>
-                  </a:tcPr>
-                </a:tc>
-                <a:tc>
-                  <a:txBody>
-                    <a:bodyPr/>
-                    <a:lstStyle/>
-                    <a:p>
-                      <a:pPr marL="0" indent="0">
-                        <a:buNone/>
-                      </a:pPr>
-                      <a:r>
-                        <a:rPr lang="en-US" sz="630" b="1" i="0" dirty="0">
-                          <a:solidFill>
-                            <a:srgbClr val="222222"/>
-                          </a:solidFill>
-                          <a:latin typeface="Arial" pitchFamily="34" charset="0"/>
-                          <a:ea typeface="Arial" pitchFamily="34" charset="-122"/>
-                          <a:cs typeface="Arial" pitchFamily="34" charset="-120"/>
-                        </a:rPr>
                         <a:t>Mantención y check list de equipos. </a:t>
                       </a:r>
                       <a:r>
@@ -3335,7 +2860,7 @@
                       <a:tailEnd type="none" w="med" len="med"/>
                     </a:lnB>
                     <a:solidFill>
-                      <a:srgbClr val="FFFFFF"/>
+                      <a:srgbClr val="F3F6FA"/>
                     </a:solidFill>
                   </a:tcPr>
                 </a:tc>
@@ -3478,7 +3003,7 @@
                       <a:tailEnd type="none" w="med" len="med"/>
                     </a:lnB>
                     <a:solidFill>
-                      <a:srgbClr val="FFFFFF"/>
+                      <a:srgbClr val="F3F6FA"/>
                     </a:solidFill>
                   </a:tcPr>
                 </a:tc>
@@ -3557,6 +3082,481 @@
                       <a:tailEnd type="none" w="med" len="med"/>
                     </a:lnB>
                     <a:solidFill>
+                      <a:srgbClr val="F3F6FA"/>
+                    </a:solidFill>
+                  </a:tcPr>
+                </a:tc>
+                <a:tc>
+                  <a:txBody>
+                    <a:bodyPr/>
+                    <a:lstStyle/>
+                    <a:p>
+                      <a:pPr marL="0" indent="0">
+                        <a:buNone/>
+                      </a:pPr>
+                      <a:r>
+                        <a:rPr lang="en-US" sz="630" i="0" dirty="0" b="0">
+                          <a:solidFill>
+                            <a:srgbClr val="222222"/>
+                          </a:solidFill>
+                          <a:latin typeface="Arial" pitchFamily="34" charset="0"/>
+                          <a:ea typeface="Arial" pitchFamily="34" charset="-122"/>
+                          <a:cs typeface="Arial" pitchFamily="34" charset="-120"/>
+                        </a:rPr>
+                        <a:t>Certificado de mantención con respaldo / check list del turno / extintor y documentos en funda / registro fotográfico</a:t>
+                      </a:r>
+                      <a:endParaRPr lang="en-US" sz="630" dirty="0">
+                        <a:latin typeface="Arial" charset="0"/>
+                        <a:ea typeface="Arial" charset="0"/>
+                        <a:cs typeface="Arial" charset="0"/>
+                      </a:endParaRPr>
+                    </a:p>
+                  </a:txBody>
+                  <a:tcPr marL="50800" marR="50800" marT="25400" marB="25400" anchor="ctr">
+                    <a:lnL w="9525" cap="flat" cmpd="sng" algn="ctr">
+                      <a:solidFill>
+                        <a:srgbClr val="C9D3E0"/>
+                      </a:solidFill>
+                      <a:prstDash val="solid"/>
+                      <a:round/>
+                      <a:headEnd type="none" w="med" len="med"/>
+                      <a:tailEnd type="none" w="med" len="med"/>
+                    </a:lnL>
+                    <a:lnR w="9525" cap="flat" cmpd="sng" algn="ctr">
+                      <a:solidFill>
+                        <a:srgbClr val="C9D3E0"/>
+                      </a:solidFill>
+                      <a:prstDash val="solid"/>
+                      <a:round/>
+                      <a:headEnd type="none" w="med" len="med"/>
+                      <a:tailEnd type="none" w="med" len="med"/>
+                    </a:lnR>
+                    <a:lnT w="9525" cap="flat" cmpd="sng" algn="ctr">
+                      <a:solidFill>
+                        <a:srgbClr val="C9D3E0"/>
+                      </a:solidFill>
+                      <a:prstDash val="solid"/>
+                      <a:round/>
+                      <a:headEnd type="none" w="med" len="med"/>
+                      <a:tailEnd type="none" w="med" len="med"/>
+                    </a:lnT>
+                    <a:lnB w="9525" cap="flat" cmpd="sng" algn="ctr">
+                      <a:solidFill>
+                        <a:srgbClr val="C9D3E0"/>
+                      </a:solidFill>
+                      <a:prstDash val="solid"/>
+                      <a:round/>
+                      <a:headEnd type="none" w="med" len="med"/>
+                      <a:tailEnd type="none" w="med" len="med"/>
+                    </a:lnB>
+                    <a:solidFill>
+                      <a:srgbClr val="F3F6FA"/>
+                    </a:solidFill>
+                  </a:tcPr>
+                </a:tc>
+                <a:extLst>
+                  <a:ext uri="{0D108BD9-81ED-4DB2-BD59-A6C34878D82A}">
+                    <a16:rowId xmlns:a16="http://schemas.microsoft.com/office/drawing/2014/main" val="10002"/>
+                  </a:ext>
+                </a:extLst>
+              </a:tr>
+              <a:tr h="566928">
+                <a:tc>
+                  <a:txBody>
+                    <a:bodyPr/>
+                    <a:lstStyle/>
+                    <a:p>
+                      <a:pPr marL="0" indent="0" algn="ctr">
+                        <a:buNone/>
+                      </a:pPr>
+                      <a:r>
+                        <a:rPr lang="en-US" sz="1300" b="1" dirty="0">
+                          <a:solidFill>
+                            <a:srgbClr val="FFFFFF"/>
+                          </a:solidFill>
+                          <a:latin typeface="Arial" pitchFamily="34" charset="0"/>
+                          <a:ea typeface="Arial" charset="0"/>
+                          <a:cs typeface="Arial" pitchFamily="34" charset="-120"/>
+                        </a:rPr>
+                        <a:t>3</a:t>
+                      </a:r>
+                      <a:endParaRPr lang="en-US" sz="800" dirty="0">
+                        <a:latin typeface="Arial" charset="0"/>
+                        <a:ea typeface="Arial" charset="0"/>
+                        <a:cs typeface="Arial" charset="0"/>
+                      </a:endParaRPr>
+                    </a:p>
+                    <a:p>
+                      <a:pPr marL="0" indent="0" algn="ctr">
+                        <a:buNone/>
+                      </a:pPr>
+                      <a:r>
+                        <a:rPr lang="en-US" sz="750" b="1" dirty="0" i="0">
+                          <a:solidFill>
+                            <a:srgbClr val="FFFFFF"/>
+                          </a:solidFill>
+                          <a:latin typeface="Arial" pitchFamily="34" charset="0"/>
+                          <a:ea typeface="Arial" pitchFamily="34" charset="-122"/>
+                          <a:cs typeface="Arial" pitchFamily="34" charset="-120"/>
+                        </a:rPr>
+                        <a:t>N1 · CRITICIDAD ALTA</a:t>
+                      </a:r>
+                      <a:endParaRPr lang="en-US" sz="800" dirty="0">
+                        <a:latin typeface="Arial" charset="0"/>
+                        <a:ea typeface="Arial" charset="0"/>
+                        <a:cs typeface="Arial" charset="0"/>
+                      </a:endParaRPr>
+                    </a:p>
+                    <a:p>
+                      <a:pPr marL="0" indent="0" algn="ctr">
+                        <a:buNone/>
+                      </a:pPr>
+                      <a:endParaRPr lang="en-US" sz="800" dirty="0">
+                        <a:latin typeface="Arial" charset="0"/>
+                        <a:ea typeface="Arial" charset="0"/>
+                        <a:cs typeface="Arial" charset="0"/>
+                      </a:endParaRPr>
+                    </a:p>
+                  </a:txBody>
+                  <a:tcPr marL="50800" marR="50800" marT="25400" marB="25400" anchor="ctr">
+                    <a:lnL w="9525" cap="flat" cmpd="sng" algn="ctr">
+                      <a:solidFill>
+                        <a:srgbClr val="C9D3E0"/>
+                      </a:solidFill>
+                      <a:prstDash val="solid"/>
+                      <a:round/>
+                      <a:headEnd type="none" w="med" len="med"/>
+                      <a:tailEnd type="none" w="med" len="med"/>
+                    </a:lnL>
+                    <a:lnR w="9525" cap="flat" cmpd="sng" algn="ctr">
+                      <a:solidFill>
+                        <a:srgbClr val="C9D3E0"/>
+                      </a:solidFill>
+                      <a:prstDash val="solid"/>
+                      <a:round/>
+                      <a:headEnd type="none" w="med" len="med"/>
+                      <a:tailEnd type="none" w="med" len="med"/>
+                    </a:lnR>
+                    <a:lnT w="9525" cap="flat" cmpd="sng" algn="ctr">
+                      <a:solidFill>
+                        <a:srgbClr val="C9D3E0"/>
+                      </a:solidFill>
+                      <a:prstDash val="solid"/>
+                      <a:round/>
+                      <a:headEnd type="none" w="med" len="med"/>
+                      <a:tailEnd type="none" w="med" len="med"/>
+                    </a:lnT>
+                    <a:lnB w="9525" cap="flat" cmpd="sng" algn="ctr">
+                      <a:solidFill>
+                        <a:srgbClr val="C9D3E0"/>
+                      </a:solidFill>
+                      <a:prstDash val="solid"/>
+                      <a:round/>
+                      <a:headEnd type="none" w="med" len="med"/>
+                      <a:tailEnd type="none" w="med" len="med"/>
+                    </a:lnB>
+                    <a:solidFill>
+                      <a:srgbClr val="C62828"/>
+                    </a:solidFill>
+                  </a:tcPr>
+                </a:tc>
+                <a:tc>
+                  <a:txBody>
+                    <a:bodyPr/>
+                    <a:lstStyle/>
+                    <a:p>
+                      <a:pPr marL="0" indent="0">
+                        <a:buNone/>
+                      </a:pPr>
+                      <a:r>
+                        <a:rPr lang="en-US" sz="630" b="1" i="0" dirty="0">
+                          <a:solidFill>
+                            <a:srgbClr val="222222"/>
+                          </a:solidFill>
+                          <a:latin typeface="Arial" pitchFamily="34" charset="0"/>
+                          <a:ea typeface="Arial" pitchFamily="34" charset="-122"/>
+                          <a:cs typeface="Arial" pitchFamily="34" charset="-120"/>
+                        </a:rPr>
+                        <a:t>Plataformas de trabajo y andamios. </a:t>
+                      </a:r>
+                      <a:r>
+                        <a:rPr lang="en-US" sz="630" b="0" i="0" dirty="0">
+                          <a:solidFill>
+                            <a:srgbClr val="222222"/>
+                          </a:solidFill>
+                          <a:latin typeface="Arial" pitchFamily="34" charset="0"/>
+                          <a:ea typeface="Arial" pitchFamily="34" charset="-122"/>
+                          <a:cs typeface="Arial" pitchFamily="34" charset="-120"/>
+                        </a:rPr>
+                        <a:t>Verificar antes de habilitar el acceso, en andamios y plataformas de frentes y talleres misceláneos, que la estructura esté completa (horizontales, diagonales, doble baranda y rodapié) y que la tarjeta verde corresponda a su condición real; el supervisor la revisa y firma al inicio del turno.</a:t>
+                      </a:r>
+                      <a:endParaRPr lang="en-US" sz="630" dirty="0">
+                        <a:latin typeface="Arial" charset="0"/>
+                        <a:ea typeface="Arial" charset="0"/>
+                        <a:cs typeface="Arial" charset="0"/>
+                      </a:endParaRPr>
+                    </a:p>
+                    <a:p>
+                      <a:pPr marL="0" indent="0">
+                        <a:buNone/>
+                      </a:pPr>
+                      <a:r>
+                        <a:rPr lang="en-US" sz="630" b="1" dirty="0" i="0">
+                          <a:solidFill>
+                            <a:srgbClr val="C62828"/>
+                          </a:solidFill>
+                          <a:latin typeface="Arial" pitchFamily="34" charset="0"/>
+                          <a:ea typeface="Arial" pitchFamily="34" charset="-122"/>
+                          <a:cs typeface="Arial" pitchFamily="34" charset="-120"/>
+                        </a:rPr>
+                        <a:t>Criterio de restricción: </a:t>
+                      </a:r>
+                      <a:r>
+                        <a:rPr lang="en-US" sz="630" b="0" dirty="0" i="0">
+                          <a:solidFill>
+                            <a:srgbClr val="222222"/>
+                          </a:solidFill>
+                          <a:latin typeface="Arial" pitchFamily="34" charset="0"/>
+                          <a:ea typeface="Arial" pitchFamily="34" charset="-122"/>
+                          <a:cs typeface="Arial" pitchFamily="34" charset="-120"/>
+                        </a:rPr>
+                        <a:t>No se usa andamio ni plataforma con piezas faltantes o con tarjeta que no refleje su condición; se bloquea el acceso.</a:t>
+                      </a:r>
+                      <a:endParaRPr lang="en-US" sz="630" dirty="0">
+                        <a:latin typeface="Arial" charset="0"/>
+                        <a:ea typeface="Arial" charset="0"/>
+                        <a:cs typeface="Arial" charset="0"/>
+                      </a:endParaRPr>
+                    </a:p>
+                  </a:txBody>
+                  <a:tcPr marL="50800" marR="50800" marT="25400" marB="25400" anchor="ctr">
+                    <a:lnL w="9525" cap="flat" cmpd="sng" algn="ctr">
+                      <a:solidFill>
+                        <a:srgbClr val="C9D3E0"/>
+                      </a:solidFill>
+                      <a:prstDash val="solid"/>
+                      <a:round/>
+                      <a:headEnd type="none" w="med" len="med"/>
+                      <a:tailEnd type="none" w="med" len="med"/>
+                    </a:lnL>
+                    <a:lnR w="9525" cap="flat" cmpd="sng" algn="ctr">
+                      <a:solidFill>
+                        <a:srgbClr val="C9D3E0"/>
+                      </a:solidFill>
+                      <a:prstDash val="solid"/>
+                      <a:round/>
+                      <a:headEnd type="none" w="med" len="med"/>
+                      <a:tailEnd type="none" w="med" len="med"/>
+                    </a:lnR>
+                    <a:lnT w="9525" cap="flat" cmpd="sng" algn="ctr">
+                      <a:solidFill>
+                        <a:srgbClr val="C9D3E0"/>
+                      </a:solidFill>
+                      <a:prstDash val="solid"/>
+                      <a:round/>
+                      <a:headEnd type="none" w="med" len="med"/>
+                      <a:tailEnd type="none" w="med" len="med"/>
+                    </a:lnT>
+                    <a:lnB w="9525" cap="flat" cmpd="sng" algn="ctr">
+                      <a:solidFill>
+                        <a:srgbClr val="C9D3E0"/>
+                      </a:solidFill>
+                      <a:prstDash val="solid"/>
+                      <a:round/>
+                      <a:headEnd type="none" w="med" len="med"/>
+                      <a:tailEnd type="none" w="med" len="med"/>
+                    </a:lnB>
+                    <a:solidFill>
+                      <a:srgbClr val="FFFFFF"/>
+                    </a:solidFill>
+                  </a:tcPr>
+                </a:tc>
+                <a:tc>
+                  <a:txBody>
+                    <a:bodyPr/>
+                    <a:lstStyle/>
+                    <a:p>
+                      <a:pPr marL="0" indent="0">
+                        <a:buNone/>
+                      </a:pPr>
+                      <a:r>
+                        <a:rPr lang="en-US" sz="620" b="1" dirty="0" i="0">
+                          <a:solidFill>
+                            <a:srgbClr val="222222"/>
+                          </a:solidFill>
+                          <a:latin typeface="Arial" pitchFamily="34" charset="0"/>
+                          <a:ea typeface="Arial" pitchFamily="34" charset="-122"/>
+                          <a:cs typeface="Arial" pitchFamily="34" charset="-120"/>
+                        </a:rPr>
+                        <a:t>HAP ID 563727 – COX:</a:t>
+                      </a:r>
+                      <a:r>
+                        <a:rPr lang="en-US" sz="620" b="0" dirty="0" i="0">
+                          <a:solidFill>
+                            <a:srgbClr val="222222"/>
+                          </a:solidFill>
+                          <a:latin typeface="Arial" pitchFamily="34" charset="0"/>
+                          <a:ea typeface="Arial" pitchFamily="34" charset="-122"/>
+                          <a:cs typeface="Arial" pitchFamily="34" charset="-120"/>
+                        </a:rPr>
+                        <a:t> andamio con tarjeta verde sin algunas piezas horizontales en su base (evento aislado).</a:t>
+                      </a:r>
+                      <a:endParaRPr lang="en-US" sz="620" dirty="0">
+                        <a:latin typeface="Arial" charset="0"/>
+                        <a:ea typeface="Arial" charset="0"/>
+                        <a:cs typeface="Arial" charset="0"/>
+                      </a:endParaRPr>
+                    </a:p>
+                    <a:p>
+                      <a:pPr marL="0" indent="0">
+                        <a:buNone/>
+                      </a:pPr>
+                      <a:r>
+                        <a:rPr lang="en-US" sz="620" b="1" dirty="0" i="0">
+                          <a:solidFill>
+                            <a:srgbClr val="222222"/>
+                          </a:solidFill>
+                          <a:latin typeface="Arial" pitchFamily="34" charset="0"/>
+                          <a:ea typeface="Arial" pitchFamily="34" charset="-122"/>
+                          <a:cs typeface="Arial" pitchFamily="34" charset="-120"/>
+                        </a:rPr>
+                        <a:t>Solicitud de supervisión:</a:t>
+                      </a:r>
+                      <a:r>
+                        <a:rPr lang="en-US" sz="620" b="0" dirty="0" i="0">
+                          <a:solidFill>
+                            <a:srgbClr val="222222"/>
+                          </a:solidFill>
+                          <a:latin typeface="Arial" pitchFamily="34" charset="0"/>
+                          <a:ea typeface="Arial" pitchFamily="34" charset="-122"/>
+                          <a:cs typeface="Arial" pitchFamily="34" charset="-120"/>
+                        </a:rPr>
+                        <a:t> desviaciones en plataformas de trabajo de talleres misceláneos.</a:t>
+                      </a:r>
+                      <a:endParaRPr lang="en-US" sz="620" dirty="0">
+                        <a:latin typeface="Arial" charset="0"/>
+                        <a:ea typeface="Arial" charset="0"/>
+                        <a:cs typeface="Arial" charset="0"/>
+                      </a:endParaRPr>
+                    </a:p>
+                  </a:txBody>
+                  <a:tcPr marL="50800" marR="50800" marT="25400" marB="25400" anchor="ctr">
+                    <a:lnL w="9525" cap="flat" cmpd="sng" algn="ctr">
+                      <a:solidFill>
+                        <a:srgbClr val="C9D3E0"/>
+                      </a:solidFill>
+                      <a:prstDash val="solid"/>
+                      <a:round/>
+                      <a:headEnd type="none" w="med" len="med"/>
+                      <a:tailEnd type="none" w="med" len="med"/>
+                    </a:lnL>
+                    <a:lnR w="9525" cap="flat" cmpd="sng" algn="ctr">
+                      <a:solidFill>
+                        <a:srgbClr val="C9D3E0"/>
+                      </a:solidFill>
+                      <a:prstDash val="solid"/>
+                      <a:round/>
+                      <a:headEnd type="none" w="med" len="med"/>
+                      <a:tailEnd type="none" w="med" len="med"/>
+                    </a:lnR>
+                    <a:lnT w="9525" cap="flat" cmpd="sng" algn="ctr">
+                      <a:solidFill>
+                        <a:srgbClr val="C9D3E0"/>
+                      </a:solidFill>
+                      <a:prstDash val="solid"/>
+                      <a:round/>
+                      <a:headEnd type="none" w="med" len="med"/>
+                      <a:tailEnd type="none" w="med" len="med"/>
+                    </a:lnT>
+                    <a:lnB w="9525" cap="flat" cmpd="sng" algn="ctr">
+                      <a:solidFill>
+                        <a:srgbClr val="C9D3E0"/>
+                      </a:solidFill>
+                      <a:prstDash val="solid"/>
+                      <a:round/>
+                      <a:headEnd type="none" w="med" len="med"/>
+                      <a:tailEnd type="none" w="med" len="med"/>
+                    </a:lnB>
+                    <a:solidFill>
+                      <a:srgbClr val="FFFFFF"/>
+                    </a:solidFill>
+                  </a:tcPr>
+                </a:tc>
+                <a:tc>
+                  <a:txBody>
+                    <a:bodyPr/>
+                    <a:lstStyle/>
+                    <a:p>
+                      <a:pPr marL="0" indent="0">
+                        <a:buNone/>
+                      </a:pPr>
+                      <a:r>
+                        <a:rPr lang="en-US" sz="630" i="0" dirty="0" b="1">
+                          <a:solidFill>
+                            <a:srgbClr val="222222"/>
+                          </a:solidFill>
+                          <a:latin typeface="Arial" pitchFamily="34" charset="0"/>
+                          <a:ea typeface="Arial" pitchFamily="34" charset="-122"/>
+                          <a:cs typeface="Arial" pitchFamily="34" charset="-120"/>
+                        </a:rPr>
+                        <a:t>Inspección de Plataformas + CdP Trabajos en Altura + ASP</a:t>
+                      </a:r>
+                      <a:r>
+                        <a:rPr lang="en-US" sz="630" i="0" dirty="0" b="0">
+                          <a:solidFill>
+                            <a:srgbClr val="222222"/>
+                          </a:solidFill>
+                          <a:latin typeface="Arial" pitchFamily="34" charset="0"/>
+                          <a:ea typeface="Arial" pitchFamily="34" charset="-122"/>
+                          <a:cs typeface="Arial" pitchFamily="34" charset="-120"/>
+                        </a:rPr>
+                        <a:t>: inspección al inicio del turno en Ripio Mina y talleres misceláneos, antes de habilitar el acceso.</a:t>
+                      </a:r>
+                      <a:endParaRPr lang="en-US" sz="630" dirty="0">
+                        <a:latin typeface="Arial" charset="0"/>
+                        <a:ea typeface="Arial" charset="0"/>
+                        <a:cs typeface="Arial" charset="0"/>
+                      </a:endParaRPr>
+                    </a:p>
+                  </a:txBody>
+                  <a:tcPr marL="50800" marR="50800" marT="25400" marB="25400" anchor="ctr">
+                    <a:lnL w="9525" cap="flat" cmpd="sng" algn="ctr">
+                      <a:solidFill>
+                        <a:srgbClr val="C9D3E0"/>
+                      </a:solidFill>
+                      <a:prstDash val="solid"/>
+                      <a:round/>
+                      <a:headEnd type="none" w="med" len="med"/>
+                      <a:tailEnd type="none" w="med" len="med"/>
+                    </a:lnL>
+                    <a:lnR w="9525" cap="flat" cmpd="sng" algn="ctr">
+                      <a:solidFill>
+                        <a:srgbClr val="C9D3E0"/>
+                      </a:solidFill>
+                      <a:prstDash val="solid"/>
+                      <a:round/>
+                      <a:headEnd type="none" w="med" len="med"/>
+                      <a:tailEnd type="none" w="med" len="med"/>
+                    </a:lnR>
+                    <a:lnT w="9525" cap="flat" cmpd="sng" algn="ctr">
+                      <a:solidFill>
+                        <a:srgbClr val="C9D3E0"/>
+                      </a:solidFill>
+                      <a:prstDash val="solid"/>
+                      <a:round/>
+                      <a:headEnd type="none" w="med" len="med"/>
+                      <a:tailEnd type="none" w="med" len="med"/>
+                    </a:lnT>
+                    <a:lnB w="9525" cap="flat" cmpd="sng" algn="ctr">
+                      <a:solidFill>
+                        <a:srgbClr val="C9D3E0"/>
+                      </a:solidFill>
+                      <a:prstDash val="solid"/>
+                      <a:round/>
+                      <a:headEnd type="none" w="med" len="med"/>
+                      <a:tailEnd type="none" w="med" len="med"/>
+                    </a:lnB>
+                    <a:solidFill>
                       <a:srgbClr val="FFFFFF"/>
                     </a:solidFill>
                   </a:tcPr>
@@ -3578,7 +3578,7 @@
                           <a:ea typeface="Arial" pitchFamily="34" charset="-122"/>
                           <a:cs typeface="Arial" pitchFamily="34" charset="-120"/>
                         </a:rPr>
-                        <a:t>Certificado de mantención con respaldo / check list del turno / extintor y documentos en funda / registro fotográfico</a:t>
+                        <a:t>Andamio completo / tarjeta coherente con la condición real y firmada / registro fotográfico</a:t>
                       </a:r>
                       <a:endParaRPr lang="en-US" sz="630" dirty="0">
                         <a:latin typeface="Arial" charset="0"/>
@@ -3674,7 +3674,7 @@
                           <a:ea typeface="Arial" pitchFamily="34" charset="-122"/>
                           <a:cs typeface="Arial" pitchFamily="34" charset="-120"/>
                         </a:rPr>
-                        <a:t>N1 · CRITICIDAD ALTA</a:t>
+                        <a:t>N2 · CRITICIDAD INTERMEDIA</a:t>
                       </a:r>
                       <a:endParaRPr lang="en-US" sz="800" dirty="0">
                         <a:latin typeface="Arial" charset="0"/>
@@ -3721,7 +3721,472 @@
                       <a:tailEnd type="none" w="med" len="med"/>
                     </a:lnB>
                     <a:solidFill>
-                      <a:srgbClr val="C62828"/>
+                      <a:srgbClr val="E67E22"/>
+                    </a:solidFill>
+                  </a:tcPr>
+                </a:tc>
+                <a:tc>
+                  <a:txBody>
+                    <a:bodyPr/>
+                    <a:lstStyle/>
+                    <a:p>
+                      <a:pPr marL="0" indent="0">
+                        <a:buNone/>
+                      </a:pPr>
+                      <a:r>
+                        <a:rPr lang="en-US" sz="630" b="1" i="0" dirty="0">
+                          <a:solidFill>
+                            <a:srgbClr val="222222"/>
+                          </a:solidFill>
+                          <a:latin typeface="Arial" pitchFamily="34" charset="0"/>
+                          <a:ea typeface="Arial" pitchFamily="34" charset="-122"/>
+                          <a:cs typeface="Arial" pitchFamily="34" charset="-120"/>
+                        </a:rPr>
+                        <a:t>Anclaje y SPDC en bordes. </a:t>
+                      </a:r>
+                      <a:r>
+                        <a:rPr lang="en-US" sz="630" b="0" i="0" dirty="0">
+                          <a:solidFill>
+                            <a:srgbClr val="222222"/>
+                          </a:solidFill>
+                          <a:latin typeface="Arial" pitchFamily="34" charset="0"/>
+                          <a:ea typeface="Arial" pitchFamily="34" charset="-122"/>
+                          <a:cs typeface="Arial" pitchFamily="34" charset="-120"/>
+                        </a:rPr>
+                        <a:t>Verificar al inicio del turno en frentes de canaletas y retiro de geosintéticos: punto de anclaje o roseta habilitado en el sector, trabajador conectado con su SPDC al trabajar próximo a bordes y arneses guardados en lugar habilitado (no dentro de tuberías); el supervisor lo confirma antes de iniciar.</a:t>
+                      </a:r>
+                      <a:endParaRPr lang="en-US" sz="630" dirty="0">
+                        <a:latin typeface="Arial" charset="0"/>
+                        <a:ea typeface="Arial" charset="0"/>
+                        <a:cs typeface="Arial" charset="0"/>
+                      </a:endParaRPr>
+                    </a:p>
+                    <a:p>
+                      <a:pPr marL="0" indent="0">
+                        <a:buNone/>
+                      </a:pPr>
+                      <a:r>
+                        <a:rPr lang="en-US" sz="630" b="1" dirty="0" i="0">
+                          <a:solidFill>
+                            <a:srgbClr val="B35C00"/>
+                          </a:solidFill>
+                          <a:latin typeface="Arial" pitchFamily="34" charset="0"/>
+                          <a:ea typeface="Arial" pitchFamily="34" charset="-122"/>
+                          <a:cs typeface="Arial" pitchFamily="34" charset="-120"/>
+                        </a:rPr>
+                        <a:t>Criterio de restricción: </a:t>
+                      </a:r>
+                      <a:r>
+                        <a:rPr lang="en-US" sz="630" b="0" dirty="0" i="0">
+                          <a:solidFill>
+                            <a:srgbClr val="222222"/>
+                          </a:solidFill>
+                          <a:latin typeface="Arial" pitchFamily="34" charset="0"/>
+                          <a:ea typeface="Arial" pitchFamily="34" charset="-122"/>
+                          <a:cs typeface="Arial" pitchFamily="34" charset="-120"/>
+                        </a:rPr>
+                        <a:t>Se detiene la tarea si hay trabajadores próximos a bordes o desniveles sin anclaje habilitado o sin su SPDC conectado.</a:t>
+                      </a:r>
+                      <a:endParaRPr lang="en-US" sz="630" dirty="0">
+                        <a:latin typeface="Arial" charset="0"/>
+                        <a:ea typeface="Arial" charset="0"/>
+                        <a:cs typeface="Arial" charset="0"/>
+                      </a:endParaRPr>
+                    </a:p>
+                  </a:txBody>
+                  <a:tcPr marL="50800" marR="50800" marT="25400" marB="25400" anchor="ctr">
+                    <a:lnL w="9525" cap="flat" cmpd="sng" algn="ctr">
+                      <a:solidFill>
+                        <a:srgbClr val="C9D3E0"/>
+                      </a:solidFill>
+                      <a:prstDash val="solid"/>
+                      <a:round/>
+                      <a:headEnd type="none" w="med" len="med"/>
+                      <a:tailEnd type="none" w="med" len="med"/>
+                    </a:lnL>
+                    <a:lnR w="9525" cap="flat" cmpd="sng" algn="ctr">
+                      <a:solidFill>
+                        <a:srgbClr val="C9D3E0"/>
+                      </a:solidFill>
+                      <a:prstDash val="solid"/>
+                      <a:round/>
+                      <a:headEnd type="none" w="med" len="med"/>
+                      <a:tailEnd type="none" w="med" len="med"/>
+                    </a:lnR>
+                    <a:lnT w="9525" cap="flat" cmpd="sng" algn="ctr">
+                      <a:solidFill>
+                        <a:srgbClr val="C9D3E0"/>
+                      </a:solidFill>
+                      <a:prstDash val="solid"/>
+                      <a:round/>
+                      <a:headEnd type="none" w="med" len="med"/>
+                      <a:tailEnd type="none" w="med" len="med"/>
+                    </a:lnT>
+                    <a:lnB w="9525" cap="flat" cmpd="sng" algn="ctr">
+                      <a:solidFill>
+                        <a:srgbClr val="C9D3E0"/>
+                      </a:solidFill>
+                      <a:prstDash val="solid"/>
+                      <a:round/>
+                      <a:headEnd type="none" w="med" len="med"/>
+                      <a:tailEnd type="none" w="med" len="med"/>
+                    </a:lnB>
+                    <a:solidFill>
+                      <a:srgbClr val="FFFFFF"/>
+                    </a:solidFill>
+                  </a:tcPr>
+                </a:tc>
+                <a:tc>
+                  <a:txBody>
+                    <a:bodyPr/>
+                    <a:lstStyle/>
+                    <a:p>
+                      <a:pPr marL="0" indent="0">
+                        <a:buNone/>
+                      </a:pPr>
+                      <a:r>
+                        <a:rPr lang="en-US" sz="620" b="1" dirty="0" i="0">
+                          <a:solidFill>
+                            <a:srgbClr val="222222"/>
+                          </a:solidFill>
+                          <a:latin typeface="Arial" pitchFamily="34" charset="0"/>
+                          <a:ea typeface="Arial" pitchFamily="34" charset="-122"/>
+                          <a:cs typeface="Arial" pitchFamily="34" charset="-120"/>
+                        </a:rPr>
+                        <a:t>CBP ID 564344 – PUMA:</a:t>
+                      </a:r>
+                      <a:r>
+                        <a:rPr lang="en-US" sz="620" b="0" dirty="0" i="0">
+                          <a:solidFill>
+                            <a:srgbClr val="222222"/>
+                          </a:solidFill>
+                          <a:latin typeface="Arial" pitchFamily="34" charset="0"/>
+                          <a:ea typeface="Arial" pitchFamily="34" charset="-122"/>
+                          <a:cs typeface="Arial" pitchFamily="34" charset="-120"/>
+                        </a:rPr>
+                        <a:t> trabajador en borde de canaleta recibiendo láminas HDPE, sin conectar su SPDC a la roseta.</a:t>
+                      </a:r>
+                      <a:endParaRPr lang="en-US" sz="620" dirty="0">
+                        <a:latin typeface="Arial" charset="0"/>
+                        <a:ea typeface="Arial" charset="0"/>
+                        <a:cs typeface="Arial" charset="0"/>
+                      </a:endParaRPr>
+                    </a:p>
+                    <a:p>
+                      <a:pPr marL="0" indent="0">
+                        <a:buNone/>
+                      </a:pPr>
+                      <a:r>
+                        <a:rPr lang="en-US" sz="620" b="1" dirty="0" i="0">
+                          <a:solidFill>
+                            <a:srgbClr val="222222"/>
+                          </a:solidFill>
+                          <a:latin typeface="Arial" pitchFamily="34" charset="0"/>
+                          <a:ea typeface="Arial" pitchFamily="34" charset="-122"/>
+                          <a:cs typeface="Arial" pitchFamily="34" charset="-120"/>
+                        </a:rPr>
+                        <a:t>HBP ID 564341 / 564353 – PUMA:</a:t>
+                      </a:r>
+                      <a:r>
+                        <a:rPr lang="en-US" sz="620" b="0" dirty="0" i="0">
+                          <a:solidFill>
+                            <a:srgbClr val="222222"/>
+                          </a:solidFill>
+                          <a:latin typeface="Arial" pitchFamily="34" charset="0"/>
+                          <a:ea typeface="Arial" pitchFamily="34" charset="-122"/>
+                          <a:cs typeface="Arial" pitchFamily="34" charset="-120"/>
+                        </a:rPr>
+                        <a:t> sin anclaje para SPDC en retiro de geosintéticos / arnés acopiado dentro de tubería.</a:t>
+                      </a:r>
+                      <a:endParaRPr lang="en-US" sz="620" dirty="0">
+                        <a:latin typeface="Arial" charset="0"/>
+                        <a:ea typeface="Arial" charset="0"/>
+                        <a:cs typeface="Arial" charset="0"/>
+                      </a:endParaRPr>
+                    </a:p>
+                  </a:txBody>
+                  <a:tcPr marL="50800" marR="50800" marT="25400" marB="25400" anchor="ctr">
+                    <a:lnL w="9525" cap="flat" cmpd="sng" algn="ctr">
+                      <a:solidFill>
+                        <a:srgbClr val="C9D3E0"/>
+                      </a:solidFill>
+                      <a:prstDash val="solid"/>
+                      <a:round/>
+                      <a:headEnd type="none" w="med" len="med"/>
+                      <a:tailEnd type="none" w="med" len="med"/>
+                    </a:lnL>
+                    <a:lnR w="9525" cap="flat" cmpd="sng" algn="ctr">
+                      <a:solidFill>
+                        <a:srgbClr val="C9D3E0"/>
+                      </a:solidFill>
+                      <a:prstDash val="solid"/>
+                      <a:round/>
+                      <a:headEnd type="none" w="med" len="med"/>
+                      <a:tailEnd type="none" w="med" len="med"/>
+                    </a:lnR>
+                    <a:lnT w="9525" cap="flat" cmpd="sng" algn="ctr">
+                      <a:solidFill>
+                        <a:srgbClr val="C9D3E0"/>
+                      </a:solidFill>
+                      <a:prstDash val="solid"/>
+                      <a:round/>
+                      <a:headEnd type="none" w="med" len="med"/>
+                      <a:tailEnd type="none" w="med" len="med"/>
+                    </a:lnT>
+                    <a:lnB w="9525" cap="flat" cmpd="sng" algn="ctr">
+                      <a:solidFill>
+                        <a:srgbClr val="C9D3E0"/>
+                      </a:solidFill>
+                      <a:prstDash val="solid"/>
+                      <a:round/>
+                      <a:headEnd type="none" w="med" len="med"/>
+                      <a:tailEnd type="none" w="med" len="med"/>
+                    </a:lnB>
+                    <a:solidFill>
+                      <a:srgbClr val="FFFFFF"/>
+                    </a:solidFill>
+                  </a:tcPr>
+                </a:tc>
+                <a:tc>
+                  <a:txBody>
+                    <a:bodyPr/>
+                    <a:lstStyle/>
+                    <a:p>
+                      <a:pPr marL="0" indent="0">
+                        <a:buNone/>
+                      </a:pPr>
+                      <a:r>
+                        <a:rPr lang="en-US" sz="630" i="0" dirty="0" b="1">
+                          <a:solidFill>
+                            <a:srgbClr val="222222"/>
+                          </a:solidFill>
+                          <a:latin typeface="Arial" pitchFamily="34" charset="0"/>
+                          <a:ea typeface="Arial" pitchFamily="34" charset="-122"/>
+                          <a:cs typeface="Arial" pitchFamily="34" charset="-120"/>
+                        </a:rPr>
+                        <a:t>GCC + CdP Trabajos en Altura + ASP</a:t>
+                      </a:r>
+                      <a:r>
+                        <a:rPr lang="en-US" sz="630" i="0" dirty="0" b="0">
+                          <a:solidFill>
+                            <a:srgbClr val="222222"/>
+                          </a:solidFill>
+                          <a:latin typeface="Arial" pitchFamily="34" charset="0"/>
+                          <a:ea typeface="Arial" pitchFamily="34" charset="-122"/>
+                          <a:cs typeface="Arial" pitchFamily="34" charset="-120"/>
+                        </a:rPr>
+                        <a:t>: GCC de anclaje y SPDC al inicio del turno en cada frente de canaletas; ASP antes de trabajar en bordes.</a:t>
+                      </a:r>
+                      <a:endParaRPr lang="en-US" sz="630" dirty="0">
+                        <a:latin typeface="Arial" charset="0"/>
+                        <a:ea typeface="Arial" charset="0"/>
+                        <a:cs typeface="Arial" charset="0"/>
+                      </a:endParaRPr>
+                    </a:p>
+                  </a:txBody>
+                  <a:tcPr marL="50800" marR="50800" marT="25400" marB="25400" anchor="ctr">
+                    <a:lnL w="9525" cap="flat" cmpd="sng" algn="ctr">
+                      <a:solidFill>
+                        <a:srgbClr val="C9D3E0"/>
+                      </a:solidFill>
+                      <a:prstDash val="solid"/>
+                      <a:round/>
+                      <a:headEnd type="none" w="med" len="med"/>
+                      <a:tailEnd type="none" w="med" len="med"/>
+                    </a:lnL>
+                    <a:lnR w="9525" cap="flat" cmpd="sng" algn="ctr">
+                      <a:solidFill>
+                        <a:srgbClr val="C9D3E0"/>
+                      </a:solidFill>
+                      <a:prstDash val="solid"/>
+                      <a:round/>
+                      <a:headEnd type="none" w="med" len="med"/>
+                      <a:tailEnd type="none" w="med" len="med"/>
+                    </a:lnR>
+                    <a:lnT w="9525" cap="flat" cmpd="sng" algn="ctr">
+                      <a:solidFill>
+                        <a:srgbClr val="C9D3E0"/>
+                      </a:solidFill>
+                      <a:prstDash val="solid"/>
+                      <a:round/>
+                      <a:headEnd type="none" w="med" len="med"/>
+                      <a:tailEnd type="none" w="med" len="med"/>
+                    </a:lnT>
+                    <a:lnB w="9525" cap="flat" cmpd="sng" algn="ctr">
+                      <a:solidFill>
+                        <a:srgbClr val="C9D3E0"/>
+                      </a:solidFill>
+                      <a:prstDash val="solid"/>
+                      <a:round/>
+                      <a:headEnd type="none" w="med" len="med"/>
+                      <a:tailEnd type="none" w="med" len="med"/>
+                    </a:lnB>
+                    <a:solidFill>
+                      <a:srgbClr val="FFFFFF"/>
+                    </a:solidFill>
+                  </a:tcPr>
+                </a:tc>
+                <a:tc>
+                  <a:txBody>
+                    <a:bodyPr/>
+                    <a:lstStyle/>
+                    <a:p>
+                      <a:pPr marL="0" indent="0">
+                        <a:buNone/>
+                      </a:pPr>
+                      <a:r>
+                        <a:rPr lang="en-US" sz="630" i="0" dirty="0" b="0">
+                          <a:solidFill>
+                            <a:srgbClr val="222222"/>
+                          </a:solidFill>
+                          <a:latin typeface="Arial" pitchFamily="34" charset="0"/>
+                          <a:ea typeface="Arial" pitchFamily="34" charset="-122"/>
+                          <a:cs typeface="Arial" pitchFamily="34" charset="-120"/>
+                        </a:rPr>
+                        <a:t>Anclaje o roseta identificado / trabajador conectado al SPDC / arnés en lugar habilitado / registro fotográfico</a:t>
+                      </a:r>
+                      <a:endParaRPr lang="en-US" sz="630" dirty="0">
+                        <a:latin typeface="Arial" charset="0"/>
+                        <a:ea typeface="Arial" charset="0"/>
+                        <a:cs typeface="Arial" charset="0"/>
+                      </a:endParaRPr>
+                    </a:p>
+                  </a:txBody>
+                  <a:tcPr marL="50800" marR="50800" marT="25400" marB="25400" anchor="ctr">
+                    <a:lnL w="9525" cap="flat" cmpd="sng" algn="ctr">
+                      <a:solidFill>
+                        <a:srgbClr val="C9D3E0"/>
+                      </a:solidFill>
+                      <a:prstDash val="solid"/>
+                      <a:round/>
+                      <a:headEnd type="none" w="med" len="med"/>
+                      <a:tailEnd type="none" w="med" len="med"/>
+                    </a:lnL>
+                    <a:lnR w="9525" cap="flat" cmpd="sng" algn="ctr">
+                      <a:solidFill>
+                        <a:srgbClr val="C9D3E0"/>
+                      </a:solidFill>
+                      <a:prstDash val="solid"/>
+                      <a:round/>
+                      <a:headEnd type="none" w="med" len="med"/>
+                      <a:tailEnd type="none" w="med" len="med"/>
+                    </a:lnR>
+                    <a:lnT w="9525" cap="flat" cmpd="sng" algn="ctr">
+                      <a:solidFill>
+                        <a:srgbClr val="C9D3E0"/>
+                      </a:solidFill>
+                      <a:prstDash val="solid"/>
+                      <a:round/>
+                      <a:headEnd type="none" w="med" len="med"/>
+                      <a:tailEnd type="none" w="med" len="med"/>
+                    </a:lnT>
+                    <a:lnB w="9525" cap="flat" cmpd="sng" algn="ctr">
+                      <a:solidFill>
+                        <a:srgbClr val="C9D3E0"/>
+                      </a:solidFill>
+                      <a:prstDash val="solid"/>
+                      <a:round/>
+                      <a:headEnd type="none" w="med" len="med"/>
+                      <a:tailEnd type="none" w="med" len="med"/>
+                    </a:lnB>
+                    <a:solidFill>
+                      <a:srgbClr val="FFFFFF"/>
+                    </a:solidFill>
+                  </a:tcPr>
+                </a:tc>
+                <a:extLst>
+                  <a:ext uri="{0D108BD9-81ED-4DB2-BD59-A6C34878D82A}">
+                    <a16:rowId xmlns:a16="http://schemas.microsoft.com/office/drawing/2014/main" val="10005"/>
+                  </a:ext>
+                </a:extLst>
+              </a:tr>
+              <a:tr h="566928">
+                <a:tc>
+                  <a:txBody>
+                    <a:bodyPr/>
+                    <a:lstStyle/>
+                    <a:p>
+                      <a:pPr marL="0" indent="0" algn="ctr">
+                        <a:buNone/>
+                      </a:pPr>
+                      <a:r>
+                        <a:rPr lang="en-US" sz="1300" b="1" dirty="0">
+                          <a:solidFill>
+                            <a:srgbClr val="FFFFFF"/>
+                          </a:solidFill>
+                          <a:latin typeface="Arial" pitchFamily="34" charset="0"/>
+                          <a:ea typeface="Arial" charset="0"/>
+                          <a:cs typeface="Arial" pitchFamily="34" charset="-120"/>
+                        </a:rPr>
+                        <a:t>5</a:t>
+                      </a:r>
+                      <a:endParaRPr lang="en-US" sz="800" dirty="0">
+                        <a:latin typeface="Arial" charset="0"/>
+                        <a:ea typeface="Arial" charset="0"/>
+                        <a:cs typeface="Arial" charset="0"/>
+                      </a:endParaRPr>
+                    </a:p>
+                    <a:p>
+                      <a:pPr marL="0" indent="0" algn="ctr">
+                        <a:buNone/>
+                      </a:pPr>
+                      <a:r>
+                        <a:rPr lang="en-US" sz="750" b="1" dirty="0" i="0">
+                          <a:solidFill>
+                            <a:srgbClr val="FFFFFF"/>
+                          </a:solidFill>
+                          <a:latin typeface="Arial" pitchFamily="34" charset="0"/>
+                          <a:ea typeface="Arial" pitchFamily="34" charset="-122"/>
+                          <a:cs typeface="Arial" pitchFamily="34" charset="-120"/>
+                        </a:rPr>
+                        <a:t>N2 · CRITICIDAD INTERMEDIA</a:t>
+                      </a:r>
+                      <a:endParaRPr lang="en-US" sz="800" dirty="0">
+                        <a:latin typeface="Arial" charset="0"/>
+                        <a:ea typeface="Arial" charset="0"/>
+                        <a:cs typeface="Arial" charset="0"/>
+                      </a:endParaRPr>
+                    </a:p>
+                  </a:txBody>
+                  <a:tcPr marL="50800" marR="50800" marT="25400" marB="25400" anchor="ctr">
+                    <a:lnL w="9525" cap="flat" cmpd="sng" algn="ctr">
+                      <a:solidFill>
+                        <a:srgbClr val="C9D3E0"/>
+                      </a:solidFill>
+                      <a:prstDash val="solid"/>
+                      <a:round/>
+                      <a:headEnd type="none" w="med" len="med"/>
+                      <a:tailEnd type="none" w="med" len="med"/>
+                    </a:lnL>
+                    <a:lnR w="9525" cap="flat" cmpd="sng" algn="ctr">
+                      <a:solidFill>
+                        <a:srgbClr val="C9D3E0"/>
+                      </a:solidFill>
+                      <a:prstDash val="solid"/>
+                      <a:round/>
+                      <a:headEnd type="none" w="med" len="med"/>
+                      <a:tailEnd type="none" w="med" len="med"/>
+                    </a:lnR>
+                    <a:lnT w="9525" cap="flat" cmpd="sng" algn="ctr">
+                      <a:solidFill>
+                        <a:srgbClr val="C9D3E0"/>
+                      </a:solidFill>
+                      <a:prstDash val="solid"/>
+                      <a:round/>
+                      <a:headEnd type="none" w="med" len="med"/>
+                      <a:tailEnd type="none" w="med" len="med"/>
+                    </a:lnT>
+                    <a:lnB w="9525" cap="flat" cmpd="sng" algn="ctr">
+                      <a:solidFill>
+                        <a:srgbClr val="C9D3E0"/>
+                      </a:solidFill>
+                      <a:prstDash val="solid"/>
+                      <a:round/>
+                      <a:headEnd type="none" w="med" len="med"/>
+                      <a:tailEnd type="none" w="med" len="med"/>
+                    </a:lnB>
+                    <a:solidFill>
+                      <a:srgbClr val="E67E22"/>
                     </a:solidFill>
                   </a:tcPr>
                 </a:tc>
@@ -3768,7 +4233,7 @@
                       <a:r>
                         <a:rPr lang="en-US" sz="630" b="1" dirty="0" i="0">
                           <a:solidFill>
-                            <a:srgbClr val="C62828"/>
+                            <a:srgbClr val="B35C00"/>
                           </a:solidFill>
                           <a:latin typeface="Arial" pitchFamily="34" charset="0"/>
                           <a:ea typeface="Arial" pitchFamily="34" charset="-122"/>
@@ -4044,471 +4509,6 @@
                           <a:cs typeface="Arial" pitchFamily="34" charset="-120"/>
                         </a:rPr>
                         <a:t>Prensa o apoyo estable en uso / procedimiento con paso a paso / registro fotográfico</a:t>
-                      </a:r>
-                      <a:endParaRPr lang="en-US" sz="630" dirty="0">
-                        <a:latin typeface="Arial" charset="0"/>
-                        <a:ea typeface="Arial" charset="0"/>
-                        <a:cs typeface="Arial" charset="0"/>
-                      </a:endParaRPr>
-                    </a:p>
-                  </a:txBody>
-                  <a:tcPr marL="50800" marR="50800" marT="25400" marB="25400" anchor="ctr">
-                    <a:lnL w="9525" cap="flat" cmpd="sng" algn="ctr">
-                      <a:solidFill>
-                        <a:srgbClr val="C9D3E0"/>
-                      </a:solidFill>
-                      <a:prstDash val="solid"/>
-                      <a:round/>
-                      <a:headEnd type="none" w="med" len="med"/>
-                      <a:tailEnd type="none" w="med" len="med"/>
-                    </a:lnL>
-                    <a:lnR w="9525" cap="flat" cmpd="sng" algn="ctr">
-                      <a:solidFill>
-                        <a:srgbClr val="C9D3E0"/>
-                      </a:solidFill>
-                      <a:prstDash val="solid"/>
-                      <a:round/>
-                      <a:headEnd type="none" w="med" len="med"/>
-                      <a:tailEnd type="none" w="med" len="med"/>
-                    </a:lnR>
-                    <a:lnT w="9525" cap="flat" cmpd="sng" algn="ctr">
-                      <a:solidFill>
-                        <a:srgbClr val="C9D3E0"/>
-                      </a:solidFill>
-                      <a:prstDash val="solid"/>
-                      <a:round/>
-                      <a:headEnd type="none" w="med" len="med"/>
-                      <a:tailEnd type="none" w="med" len="med"/>
-                    </a:lnT>
-                    <a:lnB w="9525" cap="flat" cmpd="sng" algn="ctr">
-                      <a:solidFill>
-                        <a:srgbClr val="C9D3E0"/>
-                      </a:solidFill>
-                      <a:prstDash val="solid"/>
-                      <a:round/>
-                      <a:headEnd type="none" w="med" len="med"/>
-                      <a:tailEnd type="none" w="med" len="med"/>
-                    </a:lnB>
-                    <a:solidFill>
-                      <a:srgbClr val="FFFFFF"/>
-                    </a:solidFill>
-                  </a:tcPr>
-                </a:tc>
-                <a:extLst>
-                  <a:ext uri="{0D108BD9-81ED-4DB2-BD59-A6C34878D82A}">
-                    <a16:rowId xmlns:a16="http://schemas.microsoft.com/office/drawing/2014/main" val="10005"/>
-                  </a:ext>
-                </a:extLst>
-              </a:tr>
-              <a:tr h="566928">
-                <a:tc>
-                  <a:txBody>
-                    <a:bodyPr/>
-                    <a:lstStyle/>
-                    <a:p>
-                      <a:pPr marL="0" indent="0" algn="ctr">
-                        <a:buNone/>
-                      </a:pPr>
-                      <a:r>
-                        <a:rPr lang="en-US" sz="1300" b="1" dirty="0">
-                          <a:solidFill>
-                            <a:srgbClr val="FFFFFF"/>
-                          </a:solidFill>
-                          <a:latin typeface="Arial" pitchFamily="34" charset="0"/>
-                          <a:ea typeface="Arial" charset="0"/>
-                          <a:cs typeface="Arial" pitchFamily="34" charset="-120"/>
-                        </a:rPr>
-                        <a:t>5</a:t>
-                      </a:r>
-                      <a:endParaRPr lang="en-US" sz="800" dirty="0">
-                        <a:latin typeface="Arial" charset="0"/>
-                        <a:ea typeface="Arial" charset="0"/>
-                        <a:cs typeface="Arial" charset="0"/>
-                      </a:endParaRPr>
-                    </a:p>
-                    <a:p>
-                      <a:pPr marL="0" indent="0" algn="ctr">
-                        <a:buNone/>
-                      </a:pPr>
-                      <a:r>
-                        <a:rPr lang="en-US" sz="750" b="1" dirty="0" i="0">
-                          <a:solidFill>
-                            <a:srgbClr val="FFFFFF"/>
-                          </a:solidFill>
-                          <a:latin typeface="Arial" pitchFamily="34" charset="0"/>
-                          <a:ea typeface="Arial" pitchFamily="34" charset="-122"/>
-                          <a:cs typeface="Arial" pitchFamily="34" charset="-120"/>
-                        </a:rPr>
-                        <a:t>N1 · CRITICIDAD ALTA</a:t>
-                      </a:r>
-                      <a:endParaRPr lang="en-US" sz="800" dirty="0">
-                        <a:latin typeface="Arial" charset="0"/>
-                        <a:ea typeface="Arial" charset="0"/>
-                        <a:cs typeface="Arial" charset="0"/>
-                      </a:endParaRPr>
-                    </a:p>
-                  </a:txBody>
-                  <a:tcPr marL="50800" marR="50800" marT="25400" marB="25400" anchor="ctr">
-                    <a:lnL w="9525" cap="flat" cmpd="sng" algn="ctr">
-                      <a:solidFill>
-                        <a:srgbClr val="C9D3E0"/>
-                      </a:solidFill>
-                      <a:prstDash val="solid"/>
-                      <a:round/>
-                      <a:headEnd type="none" w="med" len="med"/>
-                      <a:tailEnd type="none" w="med" len="med"/>
-                    </a:lnL>
-                    <a:lnR w="9525" cap="flat" cmpd="sng" algn="ctr">
-                      <a:solidFill>
-                        <a:srgbClr val="C9D3E0"/>
-                      </a:solidFill>
-                      <a:prstDash val="solid"/>
-                      <a:round/>
-                      <a:headEnd type="none" w="med" len="med"/>
-                      <a:tailEnd type="none" w="med" len="med"/>
-                    </a:lnR>
-                    <a:lnT w="9525" cap="flat" cmpd="sng" algn="ctr">
-                      <a:solidFill>
-                        <a:srgbClr val="C9D3E0"/>
-                      </a:solidFill>
-                      <a:prstDash val="solid"/>
-                      <a:round/>
-                      <a:headEnd type="none" w="med" len="med"/>
-                      <a:tailEnd type="none" w="med" len="med"/>
-                    </a:lnT>
-                    <a:lnB w="9525" cap="flat" cmpd="sng" algn="ctr">
-                      <a:solidFill>
-                        <a:srgbClr val="C9D3E0"/>
-                      </a:solidFill>
-                      <a:prstDash val="solid"/>
-                      <a:round/>
-                      <a:headEnd type="none" w="med" len="med"/>
-                      <a:tailEnd type="none" w="med" len="med"/>
-                    </a:lnB>
-                    <a:solidFill>
-                      <a:srgbClr val="C62828"/>
-                    </a:solidFill>
-                  </a:tcPr>
-                </a:tc>
-                <a:tc>
-                  <a:txBody>
-                    <a:bodyPr/>
-                    <a:lstStyle/>
-                    <a:p>
-                      <a:pPr marL="0" indent="0">
-                        <a:buNone/>
-                      </a:pPr>
-                      <a:r>
-                        <a:rPr lang="en-US" sz="630" b="1" i="0" dirty="0">
-                          <a:solidFill>
-                            <a:srgbClr val="222222"/>
-                          </a:solidFill>
-                          <a:latin typeface="Arial" pitchFamily="34" charset="0"/>
-                          <a:ea typeface="Arial" pitchFamily="34" charset="-122"/>
-                          <a:cs typeface="Arial" pitchFamily="34" charset="-120"/>
-                        </a:rPr>
-                        <a:t>Plataformas de trabajo y andamios. </a:t>
-                      </a:r>
-                      <a:r>
-                        <a:rPr lang="en-US" sz="630" b="0" i="0" dirty="0">
-                          <a:solidFill>
-                            <a:srgbClr val="222222"/>
-                          </a:solidFill>
-                          <a:latin typeface="Arial" pitchFamily="34" charset="0"/>
-                          <a:ea typeface="Arial" pitchFamily="34" charset="-122"/>
-                          <a:cs typeface="Arial" pitchFamily="34" charset="-120"/>
-                        </a:rPr>
-                        <a:t>Verificar antes de habilitar el acceso, en andamios y plataformas de frentes y talleres misceláneos, que la estructura esté completa (horizontales, diagonales, doble baranda y rodapié) y que la tarjeta verde corresponda a su condición real; el supervisor la revisa y firma al inicio del turno.</a:t>
-                      </a:r>
-                      <a:endParaRPr lang="en-US" sz="630" dirty="0">
-                        <a:latin typeface="Arial" charset="0"/>
-                        <a:ea typeface="Arial" charset="0"/>
-                        <a:cs typeface="Arial" charset="0"/>
-                      </a:endParaRPr>
-                    </a:p>
-                    <a:p>
-                      <a:pPr marL="0" indent="0">
-                        <a:buNone/>
-                      </a:pPr>
-                      <a:r>
-                        <a:rPr lang="en-US" sz="630" b="1" dirty="0" i="0">
-                          <a:solidFill>
-                            <a:srgbClr val="C62828"/>
-                          </a:solidFill>
-                          <a:latin typeface="Arial" pitchFamily="34" charset="0"/>
-                          <a:ea typeface="Arial" pitchFamily="34" charset="-122"/>
-                          <a:cs typeface="Arial" pitchFamily="34" charset="-120"/>
-                        </a:rPr>
-                        <a:t>Criterio de restricción: </a:t>
-                      </a:r>
-                      <a:r>
-                        <a:rPr lang="en-US" sz="630" b="0" dirty="0" i="0">
-                          <a:solidFill>
-                            <a:srgbClr val="222222"/>
-                          </a:solidFill>
-                          <a:latin typeface="Arial" pitchFamily="34" charset="0"/>
-                          <a:ea typeface="Arial" pitchFamily="34" charset="-122"/>
-                          <a:cs typeface="Arial" pitchFamily="34" charset="-120"/>
-                        </a:rPr>
-                        <a:t>No se usa andamio ni plataforma con piezas faltantes o con tarjeta que no refleje su condición; se bloquea el acceso.</a:t>
-                      </a:r>
-                      <a:endParaRPr lang="en-US" sz="630" dirty="0">
-                        <a:latin typeface="Arial" charset="0"/>
-                        <a:ea typeface="Arial" charset="0"/>
-                        <a:cs typeface="Arial" charset="0"/>
-                      </a:endParaRPr>
-                    </a:p>
-                  </a:txBody>
-                  <a:tcPr marL="50800" marR="50800" marT="25400" marB="25400" anchor="ctr">
-                    <a:lnL w="9525" cap="flat" cmpd="sng" algn="ctr">
-                      <a:solidFill>
-                        <a:srgbClr val="C9D3E0"/>
-                      </a:solidFill>
-                      <a:prstDash val="solid"/>
-                      <a:round/>
-                      <a:headEnd type="none" w="med" len="med"/>
-                      <a:tailEnd type="none" w="med" len="med"/>
-                    </a:lnL>
-                    <a:lnR w="9525" cap="flat" cmpd="sng" algn="ctr">
-                      <a:solidFill>
-                        <a:srgbClr val="C9D3E0"/>
-                      </a:solidFill>
-                      <a:prstDash val="solid"/>
-                      <a:round/>
-                      <a:headEnd type="none" w="med" len="med"/>
-                      <a:tailEnd type="none" w="med" len="med"/>
-                    </a:lnR>
-                    <a:lnT w="9525" cap="flat" cmpd="sng" algn="ctr">
-                      <a:solidFill>
-                        <a:srgbClr val="C9D3E0"/>
-                      </a:solidFill>
-                      <a:prstDash val="solid"/>
-                      <a:round/>
-                      <a:headEnd type="none" w="med" len="med"/>
-                      <a:tailEnd type="none" w="med" len="med"/>
-                    </a:lnT>
-                    <a:lnB w="9525" cap="flat" cmpd="sng" algn="ctr">
-                      <a:solidFill>
-                        <a:srgbClr val="C9D3E0"/>
-                      </a:solidFill>
-                      <a:prstDash val="solid"/>
-                      <a:round/>
-                      <a:headEnd type="none" w="med" len="med"/>
-                      <a:tailEnd type="none" w="med" len="med"/>
-                    </a:lnB>
-                    <a:solidFill>
-                      <a:srgbClr val="FFFFFF"/>
-                    </a:solidFill>
-                  </a:tcPr>
-                </a:tc>
-                <a:tc>
-                  <a:txBody>
-                    <a:bodyPr/>
-                    <a:lstStyle/>
-                    <a:p>
-                      <a:pPr marL="0" indent="0">
-                        <a:buNone/>
-                      </a:pPr>
-                      <a:r>
-                        <a:rPr lang="en-US" sz="620" b="1" dirty="0" i="0">
-                          <a:solidFill>
-                            <a:srgbClr val="222222"/>
-                          </a:solidFill>
-                          <a:latin typeface="Arial" pitchFamily="34" charset="0"/>
-                          <a:ea typeface="Arial" pitchFamily="34" charset="-122"/>
-                          <a:cs typeface="Arial" pitchFamily="34" charset="-120"/>
-                        </a:rPr>
-                        <a:t>HAP ID 563727 – COX:</a:t>
-                      </a:r>
-                      <a:r>
-                        <a:rPr lang="en-US" sz="620" b="0" dirty="0" i="0">
-                          <a:solidFill>
-                            <a:srgbClr val="222222"/>
-                          </a:solidFill>
-                          <a:latin typeface="Arial" pitchFamily="34" charset="0"/>
-                          <a:ea typeface="Arial" pitchFamily="34" charset="-122"/>
-                          <a:cs typeface="Arial" pitchFamily="34" charset="-120"/>
-                        </a:rPr>
-                        <a:t> andamio con tarjeta verde sin algunas piezas horizontales en su base (evento aislado).</a:t>
-                      </a:r>
-                      <a:endParaRPr lang="en-US" sz="620" dirty="0">
-                        <a:latin typeface="Arial" charset="0"/>
-                        <a:ea typeface="Arial" charset="0"/>
-                        <a:cs typeface="Arial" charset="0"/>
-                      </a:endParaRPr>
-                    </a:p>
-                    <a:p>
-                      <a:pPr marL="0" indent="0">
-                        <a:buNone/>
-                      </a:pPr>
-                      <a:r>
-                        <a:rPr lang="en-US" sz="620" b="1" dirty="0" i="0">
-                          <a:solidFill>
-                            <a:srgbClr val="222222"/>
-                          </a:solidFill>
-                          <a:latin typeface="Arial" pitchFamily="34" charset="0"/>
-                          <a:ea typeface="Arial" pitchFamily="34" charset="-122"/>
-                          <a:cs typeface="Arial" pitchFamily="34" charset="-120"/>
-                        </a:rPr>
-                        <a:t>Solicitud de supervisión:</a:t>
-                      </a:r>
-                      <a:r>
-                        <a:rPr lang="en-US" sz="620" b="0" dirty="0" i="0">
-                          <a:solidFill>
-                            <a:srgbClr val="222222"/>
-                          </a:solidFill>
-                          <a:latin typeface="Arial" pitchFamily="34" charset="0"/>
-                          <a:ea typeface="Arial" pitchFamily="34" charset="-122"/>
-                          <a:cs typeface="Arial" pitchFamily="34" charset="-120"/>
-                        </a:rPr>
-                        <a:t> desviaciones en plataformas de trabajo de talleres misceláneos.</a:t>
-                      </a:r>
-                      <a:endParaRPr lang="en-US" sz="620" dirty="0">
-                        <a:latin typeface="Arial" charset="0"/>
-                        <a:ea typeface="Arial" charset="0"/>
-                        <a:cs typeface="Arial" charset="0"/>
-                      </a:endParaRPr>
-                    </a:p>
-                  </a:txBody>
-                  <a:tcPr marL="50800" marR="50800" marT="25400" marB="25400" anchor="ctr">
-                    <a:lnL w="9525" cap="flat" cmpd="sng" algn="ctr">
-                      <a:solidFill>
-                        <a:srgbClr val="C9D3E0"/>
-                      </a:solidFill>
-                      <a:prstDash val="solid"/>
-                      <a:round/>
-                      <a:headEnd type="none" w="med" len="med"/>
-                      <a:tailEnd type="none" w="med" len="med"/>
-                    </a:lnL>
-                    <a:lnR w="9525" cap="flat" cmpd="sng" algn="ctr">
-                      <a:solidFill>
-                        <a:srgbClr val="C9D3E0"/>
-                      </a:solidFill>
-                      <a:prstDash val="solid"/>
-                      <a:round/>
-                      <a:headEnd type="none" w="med" len="med"/>
-                      <a:tailEnd type="none" w="med" len="med"/>
-                    </a:lnR>
-                    <a:lnT w="9525" cap="flat" cmpd="sng" algn="ctr">
-                      <a:solidFill>
-                        <a:srgbClr val="C9D3E0"/>
-                      </a:solidFill>
-                      <a:prstDash val="solid"/>
-                      <a:round/>
-                      <a:headEnd type="none" w="med" len="med"/>
-                      <a:tailEnd type="none" w="med" len="med"/>
-                    </a:lnT>
-                    <a:lnB w="9525" cap="flat" cmpd="sng" algn="ctr">
-                      <a:solidFill>
-                        <a:srgbClr val="C9D3E0"/>
-                      </a:solidFill>
-                      <a:prstDash val="solid"/>
-                      <a:round/>
-                      <a:headEnd type="none" w="med" len="med"/>
-                      <a:tailEnd type="none" w="med" len="med"/>
-                    </a:lnB>
-                    <a:solidFill>
-                      <a:srgbClr val="FFFFFF"/>
-                    </a:solidFill>
-                  </a:tcPr>
-                </a:tc>
-                <a:tc>
-                  <a:txBody>
-                    <a:bodyPr/>
-                    <a:lstStyle/>
-                    <a:p>
-                      <a:pPr marL="0" indent="0">
-                        <a:buNone/>
-                      </a:pPr>
-                      <a:r>
-                        <a:rPr lang="en-US" sz="630" i="0" dirty="0" b="1">
-                          <a:solidFill>
-                            <a:srgbClr val="222222"/>
-                          </a:solidFill>
-                          <a:latin typeface="Arial" pitchFamily="34" charset="0"/>
-                          <a:ea typeface="Arial" pitchFamily="34" charset="-122"/>
-                          <a:cs typeface="Arial" pitchFamily="34" charset="-120"/>
-                        </a:rPr>
-                        <a:t>Inspección de Plataformas + CdP Trabajos en Altura + ASP</a:t>
-                      </a:r>
-                      <a:r>
-                        <a:rPr lang="en-US" sz="630" i="0" dirty="0" b="0">
-                          <a:solidFill>
-                            <a:srgbClr val="222222"/>
-                          </a:solidFill>
-                          <a:latin typeface="Arial" pitchFamily="34" charset="0"/>
-                          <a:ea typeface="Arial" pitchFamily="34" charset="-122"/>
-                          <a:cs typeface="Arial" pitchFamily="34" charset="-120"/>
-                        </a:rPr>
-                        <a:t>: inspección al inicio del turno en Ripio Mina y talleres misceláneos, antes de habilitar el acceso.</a:t>
-                      </a:r>
-                      <a:endParaRPr lang="en-US" sz="630" dirty="0">
-                        <a:latin typeface="Arial" charset="0"/>
-                        <a:ea typeface="Arial" charset="0"/>
-                        <a:cs typeface="Arial" charset="0"/>
-                      </a:endParaRPr>
-                    </a:p>
-                  </a:txBody>
-                  <a:tcPr marL="50800" marR="50800" marT="25400" marB="25400" anchor="ctr">
-                    <a:lnL w="9525" cap="flat" cmpd="sng" algn="ctr">
-                      <a:solidFill>
-                        <a:srgbClr val="C9D3E0"/>
-                      </a:solidFill>
-                      <a:prstDash val="solid"/>
-                      <a:round/>
-                      <a:headEnd type="none" w="med" len="med"/>
-                      <a:tailEnd type="none" w="med" len="med"/>
-                    </a:lnL>
-                    <a:lnR w="9525" cap="flat" cmpd="sng" algn="ctr">
-                      <a:solidFill>
-                        <a:srgbClr val="C9D3E0"/>
-                      </a:solidFill>
-                      <a:prstDash val="solid"/>
-                      <a:round/>
-                      <a:headEnd type="none" w="med" len="med"/>
-                      <a:tailEnd type="none" w="med" len="med"/>
-                    </a:lnR>
-                    <a:lnT w="9525" cap="flat" cmpd="sng" algn="ctr">
-                      <a:solidFill>
-                        <a:srgbClr val="C9D3E0"/>
-                      </a:solidFill>
-                      <a:prstDash val="solid"/>
-                      <a:round/>
-                      <a:headEnd type="none" w="med" len="med"/>
-                      <a:tailEnd type="none" w="med" len="med"/>
-                    </a:lnT>
-                    <a:lnB w="9525" cap="flat" cmpd="sng" algn="ctr">
-                      <a:solidFill>
-                        <a:srgbClr val="C9D3E0"/>
-                      </a:solidFill>
-                      <a:prstDash val="solid"/>
-                      <a:round/>
-                      <a:headEnd type="none" w="med" len="med"/>
-                      <a:tailEnd type="none" w="med" len="med"/>
-                    </a:lnB>
-                    <a:solidFill>
-                      <a:srgbClr val="FFFFFF"/>
-                    </a:solidFill>
-                  </a:tcPr>
-                </a:tc>
-                <a:tc>
-                  <a:txBody>
-                    <a:bodyPr/>
-                    <a:lstStyle/>
-                    <a:p>
-                      <a:pPr marL="0" indent="0">
-                        <a:buNone/>
-                      </a:pPr>
-                      <a:r>
-                        <a:rPr lang="en-US" sz="630" i="0" dirty="0" b="0">
-                          <a:solidFill>
-                            <a:srgbClr val="222222"/>
-                          </a:solidFill>
-                          <a:latin typeface="Arial" pitchFamily="34" charset="0"/>
-                          <a:ea typeface="Arial" pitchFamily="34" charset="-122"/>
-                          <a:cs typeface="Arial" pitchFamily="34" charset="-120"/>
-                        </a:rPr>
-                        <a:t>Andamio completo / tarjeta coherente con la condición real y firmada / registro fotográfico</a:t>
                       </a:r>
                       <a:endParaRPr lang="en-US" sz="630" dirty="0">
                         <a:latin typeface="Arial" charset="0"/>
@@ -4816,7 +4816,7 @@
                           <a:ea typeface="Arial" charset="0"/>
                           <a:cs typeface="Arial" pitchFamily="34" charset="-120"/>
                         </a:rPr>
-                        <a:t>Regla Cardinal N°6 – Trabajos en altura (relacionada con focos 2 y 5). Medida de verificación adicional: GCC en Espacios Confinados.</a:t>
+                        <a:t>Regla Cardinal N°6 – Trabajos en altura (relacionada con focos 3 y 4). Medida de verificación adicional: GCC en Espacios Confinados.</a:t>
                       </a:r>
                       <a:endParaRPr lang="en-US" sz="620" dirty="0">
                         <a:latin typeface="Arial" charset="0"/>
@@ -5366,7 +5366,7 @@
                 <a:ea typeface="Arial" pitchFamily="34" charset="-122"/>
                 <a:cs typeface="Arial" pitchFamily="34" charset="-120"/>
               </a:rPr>
-              <a:t>✔ Anclaje y SPDC conectado en bordes (2)</a:t>
+              <a:t>✔ Mantención y check list de equipos (2)</a:t>
             </a:r>
             <a:endParaRPr lang="en-US" sz="680" dirty="0"/>
           </a:p>
@@ -5386,7 +5386,7 @@
                 <a:ea typeface="Arial" pitchFamily="34" charset="-122"/>
                 <a:cs typeface="Arial" pitchFamily="34" charset="-120"/>
               </a:rPr>
-              <a:t>✔ Mantención y check list de equipos (3)</a:t>
+              <a:t>✔ Anclaje y SPDC conectado en bordes (4)</a:t>
             </a:r>
             <a:endParaRPr lang="en-US" sz="680" dirty="0"/>
           </a:p>
@@ -5562,7 +5562,7 @@
                 <a:ea typeface="Arial" pitchFamily="34" charset="-122"/>
                 <a:cs typeface="Arial" pitchFamily="34" charset="-120"/>
               </a:rPr>
-              <a:t>✔ Sujeción de HDPE con apoyo estable (4)</a:t>
+              <a:t>✔ Andamios completos y tarjeta coherente (3)</a:t>
             </a:r>
             <a:endParaRPr lang="en-US" sz="680" dirty="0"/>
           </a:p>
@@ -5582,7 +5582,7 @@
                 <a:ea typeface="Arial" pitchFamily="34" charset="-122"/>
                 <a:cs typeface="Arial" pitchFamily="34" charset="-120"/>
               </a:rPr>
-              <a:t>✔ Andamios completos y tarjeta coherente (5)</a:t>
+              <a:t>✔ Sujeción de HDPE con apoyo estable (5)</a:t>
             </a:r>
             <a:endParaRPr lang="en-US" sz="680" dirty="0"/>
           </a:p>

</xml_diff>